<commit_message>
Add portable build guide and refresh presentation
</commit_message>
<xml_diff>
--- a/Speech_Enhancement_Project_Review.pptx
+++ b/Speech_Enhancement_Project_Review.pptx
@@ -1,30 +1,27 @@
 
 <file path=ppt/presentation.xml><?xml version="1.0" encoding="utf-8"?>
-<p:presentation xmlns:a="http://schemas.openxmlformats.org/drawingml/2006/main" xmlns:r="http://schemas.openxmlformats.org/officeDocument/2006/relationships" xmlns:p="http://schemas.openxmlformats.org/presentationml/2006/main" saveSubsetFonts="1" autoCompressPictures="0">
+<p:presentation xmlns:a="http://schemas.openxmlformats.org/drawingml/2006/main" xmlns:r="http://schemas.openxmlformats.org/officeDocument/2006/relationships" xmlns:p="http://schemas.openxmlformats.org/presentationml/2006/main" saveSubsetFonts="1">
   <p:sldMasterIdLst>
     <p:sldMasterId id="2147483648" r:id="rId1"/>
   </p:sldMasterIdLst>
   <p:sldIdLst>
-    <p:sldId id="256" r:id="rId7"/>
-    <p:sldId id="257" r:id="rId8"/>
-    <p:sldId id="258" r:id="rId9"/>
-    <p:sldId id="259" r:id="rId10"/>
-    <p:sldId id="260" r:id="rId11"/>
-    <p:sldId id="261" r:id="rId12"/>
-    <p:sldId id="262" r:id="rId13"/>
-    <p:sldId id="263" r:id="rId14"/>
-    <p:sldId id="264" r:id="rId15"/>
-    <p:sldId id="265" r:id="rId16"/>
-    <p:sldId id="266" r:id="rId17"/>
-    <p:sldId id="267" r:id="rId18"/>
+    <p:sldId id="256" r:id="rId2"/>
+    <p:sldId id="257" r:id="rId3"/>
+    <p:sldId id="258" r:id="rId4"/>
+    <p:sldId id="259" r:id="rId5"/>
+    <p:sldId id="260" r:id="rId6"/>
+    <p:sldId id="261" r:id="rId7"/>
+    <p:sldId id="262" r:id="rId8"/>
+    <p:sldId id="263" r:id="rId9"/>
+    <p:sldId id="264" r:id="rId10"/>
+    <p:sldId id="265" r:id="rId11"/>
+    <p:sldId id="266" r:id="rId12"/>
+    <p:sldId id="267" r:id="rId13"/>
   </p:sldIdLst>
-  <p:sldSz cx="12191695" cy="6858000" type="screen4x3"/>
+  <p:sldSz cx="12191695" cy="6858000"/>
   <p:notesSz cx="6858000" cy="9144000"/>
   <p:defaultTextStyle>
-    <a:defPPr>
-      <a:defRPr lang="en-US"/>
-    </a:defPPr>
-    <a:lvl1pPr marL="0" algn="l" defTabSz="457200" rtl="0" eaLnBrk="1" latinLnBrk="0" hangingPunct="1">
+    <a:lvl1pPr marL="0" algn="l" defTabSz="457200" rtl="0" eaLnBrk="1">
       <a:defRPr sz="1800" kern="1200">
         <a:solidFill>
           <a:schemeClr val="tx1"/>
@@ -34,7 +31,7 @@
         <a:cs typeface="+mn-cs"/>
       </a:defRPr>
     </a:lvl1pPr>
-    <a:lvl2pPr marL="457200" algn="l" defTabSz="457200" rtl="0" eaLnBrk="1" latinLnBrk="0" hangingPunct="1">
+    <a:lvl2pPr marL="457200" algn="l" defTabSz="457200" rtl="0" eaLnBrk="1">
       <a:defRPr sz="1800" kern="1200">
         <a:solidFill>
           <a:schemeClr val="tx1"/>
@@ -44,7 +41,7 @@
         <a:cs typeface="+mn-cs"/>
       </a:defRPr>
     </a:lvl2pPr>
-    <a:lvl3pPr marL="914400" algn="l" defTabSz="457200" rtl="0" eaLnBrk="1" latinLnBrk="0" hangingPunct="1">
+    <a:lvl3pPr marL="914400" algn="l" defTabSz="457200" rtl="0" eaLnBrk="1">
       <a:defRPr sz="1800" kern="1200">
         <a:solidFill>
           <a:schemeClr val="tx1"/>
@@ -54,7 +51,7 @@
         <a:cs typeface="+mn-cs"/>
       </a:defRPr>
     </a:lvl3pPr>
-    <a:lvl4pPr marL="1371600" algn="l" defTabSz="457200" rtl="0" eaLnBrk="1" latinLnBrk="0" hangingPunct="1">
+    <a:lvl4pPr marL="1371600" algn="l" defTabSz="457200" rtl="0" eaLnBrk="1">
       <a:defRPr sz="1800" kern="1200">
         <a:solidFill>
           <a:schemeClr val="tx1"/>
@@ -64,7 +61,7 @@
         <a:cs typeface="+mn-cs"/>
       </a:defRPr>
     </a:lvl4pPr>
-    <a:lvl5pPr marL="1828800" algn="l" defTabSz="457200" rtl="0" eaLnBrk="1" latinLnBrk="0" hangingPunct="1">
+    <a:lvl5pPr marL="1828800" algn="l" defTabSz="457200" rtl="0" eaLnBrk="1">
       <a:defRPr sz="1800" kern="1200">
         <a:solidFill>
           <a:schemeClr val="tx1"/>
@@ -74,7 +71,7 @@
         <a:cs typeface="+mn-cs"/>
       </a:defRPr>
     </a:lvl5pPr>
-    <a:lvl6pPr marL="2286000" algn="l" defTabSz="457200" rtl="0" eaLnBrk="1" latinLnBrk="0" hangingPunct="1">
+    <a:lvl6pPr marL="2286000" algn="l" defTabSz="457200" rtl="0" eaLnBrk="1">
       <a:defRPr sz="1800" kern="1200">
         <a:solidFill>
           <a:schemeClr val="tx1"/>
@@ -84,7 +81,7 @@
         <a:cs typeface="+mn-cs"/>
       </a:defRPr>
     </a:lvl6pPr>
-    <a:lvl7pPr marL="2743200" algn="l" defTabSz="457200" rtl="0" eaLnBrk="1" latinLnBrk="0" hangingPunct="1">
+    <a:lvl7pPr marL="2743200" algn="l" defTabSz="457200" rtl="0" eaLnBrk="1">
       <a:defRPr sz="1800" kern="1200">
         <a:solidFill>
           <a:schemeClr val="tx1"/>
@@ -94,7 +91,7 @@
         <a:cs typeface="+mn-cs"/>
       </a:defRPr>
     </a:lvl7pPr>
-    <a:lvl8pPr marL="3200400" algn="l" defTabSz="457200" rtl="0" eaLnBrk="1" latinLnBrk="0" hangingPunct="1">
+    <a:lvl8pPr marL="3200400" algn="l" defTabSz="457200" rtl="0" eaLnBrk="1">
       <a:defRPr sz="1800" kern="1200">
         <a:solidFill>
           <a:schemeClr val="tx1"/>
@@ -104,7 +101,7 @@
         <a:cs typeface="+mn-cs"/>
       </a:defRPr>
     </a:lvl8pPr>
-    <a:lvl9pPr marL="3657600" algn="l" defTabSz="457200" rtl="0" eaLnBrk="1" latinLnBrk="0" hangingPunct="1">
+    <a:lvl9pPr marL="3657600" algn="l" defTabSz="457200" rtl="0" eaLnBrk="1">
       <a:defRPr sz="1800" kern="1200">
         <a:solidFill>
           <a:schemeClr val="tx1"/>
@@ -150,13 +147,16 @@
             <a:off x="685800" y="2130425"/>
             <a:ext cx="7772400" cy="1470025"/>
           </a:xfrm>
+          <a:prstGeom prst="rect">
+            <a:avLst/>
+          </a:prstGeom>
         </p:spPr>
         <p:txBody>
           <a:bodyPr/>
           <a:lstStyle/>
           <a:p>
             <a:r>
-              <a:rPr lang="en-US" smtClean="0"/>
+              <a:rPr lang="en-US"/>
               <a:t>Click to edit Master title style</a:t>
             </a:r>
             <a:endParaRPr lang="en-US"/>
@@ -178,6 +178,9 @@
             <a:off x="1371600" y="3886200"/>
             <a:ext cx="6400800" cy="1752600"/>
           </a:xfrm>
+          <a:prstGeom prst="rect">
+            <a:avLst/>
+          </a:prstGeom>
         </p:spPr>
         <p:txBody>
           <a:bodyPr/>
@@ -275,7 +278,7 @@
           </a:lstStyle>
           <a:p>
             <a:r>
-              <a:rPr lang="en-US" smtClean="0"/>
+              <a:rPr lang="en-US"/>
               <a:t>Click to edit Master subtitle style</a:t>
             </a:r>
             <a:endParaRPr lang="en-US"/>
@@ -297,8 +300,8 @@
           <a:bodyPr/>
           <a:lstStyle/>
           <a:p>
-            <a:fld id="{5BCAD085-E8A6-8845-BD4E-CB4CCA059FC4}" type="datetimeFigureOut">
-              <a:rPr lang="en-US" smtClean="0"/>
+            <a:fld id="{CF395B21-E8EE-4505-87E0-7B7F2C3DBBD0}" type="datetimeFigureOut">
+              <a:rPr lang="en-US"/>
               <a:t>1/27/13</a:t>
             </a:fld>
             <a:endParaRPr lang="en-US"/>
@@ -339,8 +342,8 @@
           <a:bodyPr/>
           <a:lstStyle/>
           <a:p>
-            <a:fld id="{C1FF6DA9-008F-8B48-92A6-B652298478BF}" type="slidenum">
-              <a:rPr lang="en-US" smtClean="0"/>
+            <a:fld id="{7DDC6D5D-A00E-4AA9-84F2-364CBECE0EEA}" type="slidenum">
+              <a:rPr lang="en-US"/>
               <a:t>‹#›</a:t>
             </a:fld>
             <a:endParaRPr lang="en-US"/>
@@ -348,11 +351,6 @@
         </p:txBody>
       </p:sp>
     </p:spTree>
-    <p:extLst>
-      <p:ext uri="{BB962C8B-B14F-4D97-AF65-F5344CB8AC3E}">
-        <p14:creationId xmlns:p14="http://schemas.microsoft.com/office/powerpoint/2010/main" val="3168075583"/>
-      </p:ext>
-    </p:extLst>
   </p:cSld>
   <p:clrMapOvr>
     <a:masterClrMapping/>
@@ -393,7 +391,7 @@
           <a:lstStyle/>
           <a:p>
             <a:r>
-              <a:rPr lang="en-US" smtClean="0"/>
+              <a:rPr lang="en-US"/>
               <a:t>Click to edit Master title style</a:t>
             </a:r>
             <a:endParaRPr lang="en-US"/>
@@ -415,37 +413,36 @@
           <a:bodyPr vert="eaVert"/>
           <a:lstStyle/>
           <a:p>
-            <a:pPr lvl="0"/>
-            <a:r>
-              <a:rPr lang="en-US" smtClean="0"/>
+            <a:r>
+              <a:rPr lang="en-US"/>
               <a:t>Click to edit Master text styles</a:t>
             </a:r>
           </a:p>
           <a:p>
             <a:pPr lvl="1"/>
             <a:r>
-              <a:rPr lang="en-US" smtClean="0"/>
+              <a:rPr lang="en-US"/>
               <a:t>Second level</a:t>
             </a:r>
           </a:p>
           <a:p>
             <a:pPr lvl="2"/>
             <a:r>
-              <a:rPr lang="en-US" smtClean="0"/>
+              <a:rPr lang="en-US"/>
               <a:t>Third level</a:t>
             </a:r>
           </a:p>
           <a:p>
             <a:pPr lvl="3"/>
             <a:r>
-              <a:rPr lang="en-US" smtClean="0"/>
+              <a:rPr lang="en-US"/>
               <a:t>Fourth level</a:t>
             </a:r>
           </a:p>
           <a:p>
             <a:pPr lvl="4"/>
             <a:r>
-              <a:rPr lang="en-US" smtClean="0"/>
+              <a:rPr lang="en-US"/>
               <a:t>Fifth level</a:t>
             </a:r>
             <a:endParaRPr lang="en-US"/>
@@ -467,8 +464,8 @@
           <a:bodyPr/>
           <a:lstStyle/>
           <a:p>
-            <a:fld id="{5BCAD085-E8A6-8845-BD4E-CB4CCA059FC4}" type="datetimeFigureOut">
-              <a:rPr lang="en-US" smtClean="0"/>
+            <a:fld id="{27602B83-4DFE-444B-8222-D5FF1EA6B44C}" type="datetimeFigureOut">
+              <a:rPr lang="en-US"/>
               <a:t>1/27/13</a:t>
             </a:fld>
             <a:endParaRPr lang="en-US"/>
@@ -509,8 +506,8 @@
           <a:bodyPr/>
           <a:lstStyle/>
           <a:p>
-            <a:fld id="{C1FF6DA9-008F-8B48-92A6-B652298478BF}" type="slidenum">
-              <a:rPr lang="en-US" smtClean="0"/>
+            <a:fld id="{DE19C649-D3E0-46CB-87C1-67136E4226A6}" type="slidenum">
+              <a:rPr lang="en-US"/>
               <a:t>‹#›</a:t>
             </a:fld>
             <a:endParaRPr lang="en-US"/>
@@ -518,11 +515,6 @@
         </p:txBody>
       </p:sp>
     </p:spTree>
-    <p:extLst>
-      <p:ext uri="{BB962C8B-B14F-4D97-AF65-F5344CB8AC3E}">
-        <p14:creationId xmlns:p14="http://schemas.microsoft.com/office/powerpoint/2010/main" val="2910927964"/>
-      </p:ext>
-    </p:extLst>
   </p:cSld>
   <p:clrMapOvr>
     <a:masterClrMapping/>
@@ -562,13 +554,16 @@
             <a:off x="6629400" y="274638"/>
             <a:ext cx="2057400" cy="5851525"/>
           </a:xfrm>
+          <a:prstGeom prst="rect">
+            <a:avLst/>
+          </a:prstGeom>
         </p:spPr>
         <p:txBody>
           <a:bodyPr vert="eaVert"/>
           <a:lstStyle/>
           <a:p>
             <a:r>
-              <a:rPr lang="en-US" smtClean="0"/>
+              <a:rPr lang="en-US"/>
               <a:t>Click to edit Master title style</a:t>
             </a:r>
             <a:endParaRPr lang="en-US"/>
@@ -590,42 +585,44 @@
             <a:off x="457200" y="274638"/>
             <a:ext cx="6019800" cy="5851525"/>
           </a:xfrm>
+          <a:prstGeom prst="rect">
+            <a:avLst/>
+          </a:prstGeom>
         </p:spPr>
         <p:txBody>
           <a:bodyPr vert="eaVert"/>
           <a:lstStyle/>
           <a:p>
-            <a:pPr lvl="0"/>
-            <a:r>
-              <a:rPr lang="en-US" smtClean="0"/>
+            <a:r>
+              <a:rPr lang="en-US"/>
               <a:t>Click to edit Master text styles</a:t>
             </a:r>
           </a:p>
           <a:p>
             <a:pPr lvl="1"/>
             <a:r>
-              <a:rPr lang="en-US" smtClean="0"/>
+              <a:rPr lang="en-US"/>
               <a:t>Second level</a:t>
             </a:r>
           </a:p>
           <a:p>
             <a:pPr lvl="2"/>
             <a:r>
-              <a:rPr lang="en-US" smtClean="0"/>
+              <a:rPr lang="en-US"/>
               <a:t>Third level</a:t>
             </a:r>
           </a:p>
           <a:p>
             <a:pPr lvl="3"/>
             <a:r>
-              <a:rPr lang="en-US" smtClean="0"/>
+              <a:rPr lang="en-US"/>
               <a:t>Fourth level</a:t>
             </a:r>
           </a:p>
           <a:p>
             <a:pPr lvl="4"/>
             <a:r>
-              <a:rPr lang="en-US" smtClean="0"/>
+              <a:rPr lang="en-US"/>
               <a:t>Fifth level</a:t>
             </a:r>
             <a:endParaRPr lang="en-US"/>
@@ -647,8 +644,8 @@
           <a:bodyPr/>
           <a:lstStyle/>
           <a:p>
-            <a:fld id="{5BCAD085-E8A6-8845-BD4E-CB4CCA059FC4}" type="datetimeFigureOut">
-              <a:rPr lang="en-US" smtClean="0"/>
+            <a:fld id="{A6FA40F9-1701-4EB4-806D-4ED861E7A003}" type="datetimeFigureOut">
+              <a:rPr lang="en-US"/>
               <a:t>1/27/13</a:t>
             </a:fld>
             <a:endParaRPr lang="en-US"/>
@@ -689,8 +686,8 @@
           <a:bodyPr/>
           <a:lstStyle/>
           <a:p>
-            <a:fld id="{C1FF6DA9-008F-8B48-92A6-B652298478BF}" type="slidenum">
-              <a:rPr lang="en-US" smtClean="0"/>
+            <a:fld id="{20EBE78A-EB3E-401E-81B5-D7F53201DAF3}" type="slidenum">
+              <a:rPr lang="en-US"/>
               <a:t>‹#›</a:t>
             </a:fld>
             <a:endParaRPr lang="en-US"/>
@@ -698,11 +695,6 @@
         </p:txBody>
       </p:sp>
     </p:spTree>
-    <p:extLst>
-      <p:ext uri="{BB962C8B-B14F-4D97-AF65-F5344CB8AC3E}">
-        <p14:creationId xmlns:p14="http://schemas.microsoft.com/office/powerpoint/2010/main" val="3612223792"/>
-      </p:ext>
-    </p:extLst>
   </p:cSld>
   <p:clrMapOvr>
     <a:masterClrMapping/>
@@ -743,7 +735,7 @@
           <a:lstStyle/>
           <a:p>
             <a:r>
-              <a:rPr lang="en-US" smtClean="0"/>
+              <a:rPr lang="en-US"/>
               <a:t>Click to edit Master title style</a:t>
             </a:r>
             <a:endParaRPr lang="en-US"/>
@@ -765,37 +757,36 @@
           <a:bodyPr/>
           <a:lstStyle/>
           <a:p>
-            <a:pPr lvl="0"/>
-            <a:r>
-              <a:rPr lang="en-US" smtClean="0"/>
+            <a:r>
+              <a:rPr lang="en-US"/>
               <a:t>Click to edit Master text styles</a:t>
             </a:r>
           </a:p>
           <a:p>
             <a:pPr lvl="1"/>
             <a:r>
-              <a:rPr lang="en-US" smtClean="0"/>
+              <a:rPr lang="en-US"/>
               <a:t>Second level</a:t>
             </a:r>
           </a:p>
           <a:p>
             <a:pPr lvl="2"/>
             <a:r>
-              <a:rPr lang="en-US" smtClean="0"/>
+              <a:rPr lang="en-US"/>
               <a:t>Third level</a:t>
             </a:r>
           </a:p>
           <a:p>
             <a:pPr lvl="3"/>
             <a:r>
-              <a:rPr lang="en-US" smtClean="0"/>
+              <a:rPr lang="en-US"/>
               <a:t>Fourth level</a:t>
             </a:r>
           </a:p>
           <a:p>
             <a:pPr lvl="4"/>
             <a:r>
-              <a:rPr lang="en-US" smtClean="0"/>
+              <a:rPr lang="en-US"/>
               <a:t>Fifth level</a:t>
             </a:r>
             <a:endParaRPr lang="en-US"/>
@@ -817,8 +808,8 @@
           <a:bodyPr/>
           <a:lstStyle/>
           <a:p>
-            <a:fld id="{5BCAD085-E8A6-8845-BD4E-CB4CCA059FC4}" type="datetimeFigureOut">
-              <a:rPr lang="en-US" smtClean="0"/>
+            <a:fld id="{05E609E6-1126-4CCC-8F95-892B304C12E9}" type="datetimeFigureOut">
+              <a:rPr lang="en-US"/>
               <a:t>1/27/13</a:t>
             </a:fld>
             <a:endParaRPr lang="en-US"/>
@@ -859,8 +850,8 @@
           <a:bodyPr/>
           <a:lstStyle/>
           <a:p>
-            <a:fld id="{C1FF6DA9-008F-8B48-92A6-B652298478BF}" type="slidenum">
-              <a:rPr lang="en-US" smtClean="0"/>
+            <a:fld id="{EDCD0F9E-EF7E-4C26-8662-25A73F2263DD}" type="slidenum">
+              <a:rPr lang="en-US"/>
               <a:t>‹#›</a:t>
             </a:fld>
             <a:endParaRPr lang="en-US"/>
@@ -868,11 +859,6 @@
         </p:txBody>
       </p:sp>
     </p:spTree>
-    <p:extLst>
-      <p:ext uri="{BB962C8B-B14F-4D97-AF65-F5344CB8AC3E}">
-        <p14:creationId xmlns:p14="http://schemas.microsoft.com/office/powerpoint/2010/main" val="2614314258"/>
-      </p:ext>
-    </p:extLst>
   </p:cSld>
   <p:clrMapOvr>
     <a:masterClrMapping/>
@@ -912,6 +898,9 @@
             <a:off x="722313" y="4406900"/>
             <a:ext cx="7772400" cy="1362075"/>
           </a:xfrm>
+          <a:prstGeom prst="rect">
+            <a:avLst/>
+          </a:prstGeom>
         </p:spPr>
         <p:txBody>
           <a:bodyPr anchor="t"/>
@@ -922,7 +911,7 @@
           </a:lstStyle>
           <a:p>
             <a:r>
-              <a:rPr lang="en-US" smtClean="0"/>
+              <a:rPr lang="en-US"/>
               <a:t>Click to edit Master title style</a:t>
             </a:r>
             <a:endParaRPr lang="en-US"/>
@@ -944,6 +933,9 @@
             <a:off x="722313" y="2906713"/>
             <a:ext cx="7772400" cy="1500187"/>
           </a:xfrm>
+          <a:prstGeom prst="rect">
+            <a:avLst/>
+          </a:prstGeom>
         </p:spPr>
         <p:txBody>
           <a:bodyPr anchor="b"/>
@@ -1040,9 +1032,8 @@
             </a:lvl9pPr>
           </a:lstStyle>
           <a:p>
-            <a:pPr lvl="0"/>
-            <a:r>
-              <a:rPr lang="en-US" smtClean="0"/>
+            <a:r>
+              <a:rPr lang="en-US"/>
               <a:t>Click to edit Master text styles</a:t>
             </a:r>
           </a:p>
@@ -1063,8 +1054,8 @@
           <a:bodyPr/>
           <a:lstStyle/>
           <a:p>
-            <a:fld id="{5BCAD085-E8A6-8845-BD4E-CB4CCA059FC4}" type="datetimeFigureOut">
-              <a:rPr lang="en-US" smtClean="0"/>
+            <a:fld id="{B43082BF-5467-4883-8896-824F7369BC9A}" type="datetimeFigureOut">
+              <a:rPr lang="en-US"/>
               <a:t>1/27/13</a:t>
             </a:fld>
             <a:endParaRPr lang="en-US"/>
@@ -1105,8 +1096,8 @@
           <a:bodyPr/>
           <a:lstStyle/>
           <a:p>
-            <a:fld id="{C1FF6DA9-008F-8B48-92A6-B652298478BF}" type="slidenum">
-              <a:rPr lang="en-US" smtClean="0"/>
+            <a:fld id="{87C18080-B33E-4073-8615-72D8F5AE8F78}" type="slidenum">
+              <a:rPr lang="en-US"/>
               <a:t>‹#›</a:t>
             </a:fld>
             <a:endParaRPr lang="en-US"/>
@@ -1114,11 +1105,6 @@
         </p:txBody>
       </p:sp>
     </p:spTree>
-    <p:extLst>
-      <p:ext uri="{BB962C8B-B14F-4D97-AF65-F5344CB8AC3E}">
-        <p14:creationId xmlns:p14="http://schemas.microsoft.com/office/powerpoint/2010/main" val="960648375"/>
-      </p:ext>
-    </p:extLst>
   </p:cSld>
   <p:clrMapOvr>
     <a:masterClrMapping/>
@@ -1159,7 +1145,7 @@
           <a:lstStyle/>
           <a:p>
             <a:r>
-              <a:rPr lang="en-US" smtClean="0"/>
+              <a:rPr lang="en-US"/>
               <a:t>Click to edit Master title style</a:t>
             </a:r>
             <a:endParaRPr lang="en-US"/>
@@ -1181,6 +1167,9 @@
             <a:off x="457200" y="1600200"/>
             <a:ext cx="4038600" cy="4525963"/>
           </a:xfrm>
+          <a:prstGeom prst="rect">
+            <a:avLst/>
+          </a:prstGeom>
         </p:spPr>
         <p:txBody>
           <a:bodyPr/>
@@ -1214,37 +1203,36 @@
             </a:lvl9pPr>
           </a:lstStyle>
           <a:p>
-            <a:pPr lvl="0"/>
-            <a:r>
-              <a:rPr lang="en-US" smtClean="0"/>
+            <a:r>
+              <a:rPr lang="en-US"/>
               <a:t>Click to edit Master text styles</a:t>
             </a:r>
           </a:p>
           <a:p>
             <a:pPr lvl="1"/>
             <a:r>
-              <a:rPr lang="en-US" smtClean="0"/>
+              <a:rPr lang="en-US"/>
               <a:t>Second level</a:t>
             </a:r>
           </a:p>
           <a:p>
             <a:pPr lvl="2"/>
             <a:r>
-              <a:rPr lang="en-US" smtClean="0"/>
+              <a:rPr lang="en-US"/>
               <a:t>Third level</a:t>
             </a:r>
           </a:p>
           <a:p>
             <a:pPr lvl="3"/>
             <a:r>
-              <a:rPr lang="en-US" smtClean="0"/>
+              <a:rPr lang="en-US"/>
               <a:t>Fourth level</a:t>
             </a:r>
           </a:p>
           <a:p>
             <a:pPr lvl="4"/>
             <a:r>
-              <a:rPr lang="en-US" smtClean="0"/>
+              <a:rPr lang="en-US"/>
               <a:t>Fifth level</a:t>
             </a:r>
             <a:endParaRPr lang="en-US"/>
@@ -1266,6 +1254,9 @@
             <a:off x="4648200" y="1600200"/>
             <a:ext cx="4038600" cy="4525963"/>
           </a:xfrm>
+          <a:prstGeom prst="rect">
+            <a:avLst/>
+          </a:prstGeom>
         </p:spPr>
         <p:txBody>
           <a:bodyPr/>
@@ -1299,37 +1290,36 @@
             </a:lvl9pPr>
           </a:lstStyle>
           <a:p>
-            <a:pPr lvl="0"/>
-            <a:r>
-              <a:rPr lang="en-US" smtClean="0"/>
+            <a:r>
+              <a:rPr lang="en-US"/>
               <a:t>Click to edit Master text styles</a:t>
             </a:r>
           </a:p>
           <a:p>
             <a:pPr lvl="1"/>
             <a:r>
-              <a:rPr lang="en-US" smtClean="0"/>
+              <a:rPr lang="en-US"/>
               <a:t>Second level</a:t>
             </a:r>
           </a:p>
           <a:p>
             <a:pPr lvl="2"/>
             <a:r>
-              <a:rPr lang="en-US" smtClean="0"/>
+              <a:rPr lang="en-US"/>
               <a:t>Third level</a:t>
             </a:r>
           </a:p>
           <a:p>
             <a:pPr lvl="3"/>
             <a:r>
-              <a:rPr lang="en-US" smtClean="0"/>
+              <a:rPr lang="en-US"/>
               <a:t>Fourth level</a:t>
             </a:r>
           </a:p>
           <a:p>
             <a:pPr lvl="4"/>
             <a:r>
-              <a:rPr lang="en-US" smtClean="0"/>
+              <a:rPr lang="en-US"/>
               <a:t>Fifth level</a:t>
             </a:r>
             <a:endParaRPr lang="en-US"/>
@@ -1351,8 +1341,8 @@
           <a:bodyPr/>
           <a:lstStyle/>
           <a:p>
-            <a:fld id="{5BCAD085-E8A6-8845-BD4E-CB4CCA059FC4}" type="datetimeFigureOut">
-              <a:rPr lang="en-US" smtClean="0"/>
+            <a:fld id="{A3A66248-C912-41CA-84D9-08E1C7982093}" type="datetimeFigureOut">
+              <a:rPr lang="en-US"/>
               <a:t>1/27/13</a:t>
             </a:fld>
             <a:endParaRPr lang="en-US"/>
@@ -1393,8 +1383,8 @@
           <a:bodyPr/>
           <a:lstStyle/>
           <a:p>
-            <a:fld id="{C1FF6DA9-008F-8B48-92A6-B652298478BF}" type="slidenum">
-              <a:rPr lang="en-US" smtClean="0"/>
+            <a:fld id="{85CB9569-04AF-4288-8880-64CE52ABE7A3}" type="slidenum">
+              <a:rPr lang="en-US"/>
               <a:t>‹#›</a:t>
             </a:fld>
             <a:endParaRPr lang="en-US"/>
@@ -1402,11 +1392,6 @@
         </p:txBody>
       </p:sp>
     </p:spTree>
-    <p:extLst>
-      <p:ext uri="{BB962C8B-B14F-4D97-AF65-F5344CB8AC3E}">
-        <p14:creationId xmlns:p14="http://schemas.microsoft.com/office/powerpoint/2010/main" val="2782244947"/>
-      </p:ext>
-    </p:extLst>
   </p:cSld>
   <p:clrMapOvr>
     <a:masterClrMapping/>
@@ -1445,13 +1430,11 @@
         <p:txBody>
           <a:bodyPr/>
           <a:lstStyle>
-            <a:lvl1pPr>
-              <a:defRPr/>
-            </a:lvl1pPr>
+            <a:lvl1pPr/>
           </a:lstStyle>
           <a:p>
             <a:r>
-              <a:rPr lang="en-US" smtClean="0"/>
+              <a:rPr lang="en-US"/>
               <a:t>Click to edit Master title style</a:t>
             </a:r>
             <a:endParaRPr lang="en-US"/>
@@ -1473,6 +1456,9 @@
             <a:off x="457200" y="1535113"/>
             <a:ext cx="4040188" cy="639762"/>
           </a:xfrm>
+          <a:prstGeom prst="rect">
+            <a:avLst/>
+          </a:prstGeom>
         </p:spPr>
         <p:txBody>
           <a:bodyPr anchor="b"/>
@@ -1515,9 +1501,8 @@
             </a:lvl9pPr>
           </a:lstStyle>
           <a:p>
-            <a:pPr lvl="0"/>
-            <a:r>
-              <a:rPr lang="en-US" smtClean="0"/>
+            <a:r>
+              <a:rPr lang="en-US"/>
               <a:t>Click to edit Master text styles</a:t>
             </a:r>
           </a:p>
@@ -1538,6 +1523,9 @@
             <a:off x="457200" y="2174875"/>
             <a:ext cx="4040188" cy="3951288"/>
           </a:xfrm>
+          <a:prstGeom prst="rect">
+            <a:avLst/>
+          </a:prstGeom>
         </p:spPr>
         <p:txBody>
           <a:bodyPr/>
@@ -1571,37 +1559,36 @@
             </a:lvl9pPr>
           </a:lstStyle>
           <a:p>
-            <a:pPr lvl="0"/>
-            <a:r>
-              <a:rPr lang="en-US" smtClean="0"/>
+            <a:r>
+              <a:rPr lang="en-US"/>
               <a:t>Click to edit Master text styles</a:t>
             </a:r>
           </a:p>
           <a:p>
             <a:pPr lvl="1"/>
             <a:r>
-              <a:rPr lang="en-US" smtClean="0"/>
+              <a:rPr lang="en-US"/>
               <a:t>Second level</a:t>
             </a:r>
           </a:p>
           <a:p>
             <a:pPr lvl="2"/>
             <a:r>
-              <a:rPr lang="en-US" smtClean="0"/>
+              <a:rPr lang="en-US"/>
               <a:t>Third level</a:t>
             </a:r>
           </a:p>
           <a:p>
             <a:pPr lvl="3"/>
             <a:r>
-              <a:rPr lang="en-US" smtClean="0"/>
+              <a:rPr lang="en-US"/>
               <a:t>Fourth level</a:t>
             </a:r>
           </a:p>
           <a:p>
             <a:pPr lvl="4"/>
             <a:r>
-              <a:rPr lang="en-US" smtClean="0"/>
+              <a:rPr lang="en-US"/>
               <a:t>Fifth level</a:t>
             </a:r>
             <a:endParaRPr lang="en-US"/>
@@ -1623,6 +1610,9 @@
             <a:off x="4645025" y="1535113"/>
             <a:ext cx="4041775" cy="639762"/>
           </a:xfrm>
+          <a:prstGeom prst="rect">
+            <a:avLst/>
+          </a:prstGeom>
         </p:spPr>
         <p:txBody>
           <a:bodyPr anchor="b"/>
@@ -1665,9 +1655,8 @@
             </a:lvl9pPr>
           </a:lstStyle>
           <a:p>
-            <a:pPr lvl="0"/>
-            <a:r>
-              <a:rPr lang="en-US" smtClean="0"/>
+            <a:r>
+              <a:rPr lang="en-US"/>
               <a:t>Click to edit Master text styles</a:t>
             </a:r>
           </a:p>
@@ -1688,6 +1677,9 @@
             <a:off x="4645025" y="2174875"/>
             <a:ext cx="4041775" cy="3951288"/>
           </a:xfrm>
+          <a:prstGeom prst="rect">
+            <a:avLst/>
+          </a:prstGeom>
         </p:spPr>
         <p:txBody>
           <a:bodyPr/>
@@ -1721,37 +1713,36 @@
             </a:lvl9pPr>
           </a:lstStyle>
           <a:p>
-            <a:pPr lvl="0"/>
-            <a:r>
-              <a:rPr lang="en-US" smtClean="0"/>
+            <a:r>
+              <a:rPr lang="en-US"/>
               <a:t>Click to edit Master text styles</a:t>
             </a:r>
           </a:p>
           <a:p>
             <a:pPr lvl="1"/>
             <a:r>
-              <a:rPr lang="en-US" smtClean="0"/>
+              <a:rPr lang="en-US"/>
               <a:t>Second level</a:t>
             </a:r>
           </a:p>
           <a:p>
             <a:pPr lvl="2"/>
             <a:r>
-              <a:rPr lang="en-US" smtClean="0"/>
+              <a:rPr lang="en-US"/>
               <a:t>Third level</a:t>
             </a:r>
           </a:p>
           <a:p>
             <a:pPr lvl="3"/>
             <a:r>
-              <a:rPr lang="en-US" smtClean="0"/>
+              <a:rPr lang="en-US"/>
               <a:t>Fourth level</a:t>
             </a:r>
           </a:p>
           <a:p>
             <a:pPr lvl="4"/>
             <a:r>
-              <a:rPr lang="en-US" smtClean="0"/>
+              <a:rPr lang="en-US"/>
               <a:t>Fifth level</a:t>
             </a:r>
             <a:endParaRPr lang="en-US"/>
@@ -1773,8 +1764,8 @@
           <a:bodyPr/>
           <a:lstStyle/>
           <a:p>
-            <a:fld id="{5BCAD085-E8A6-8845-BD4E-CB4CCA059FC4}" type="datetimeFigureOut">
-              <a:rPr lang="en-US" smtClean="0"/>
+            <a:fld id="{54EFB636-F4D9-4299-85F9-44D23E27C49C}" type="datetimeFigureOut">
+              <a:rPr lang="en-US"/>
               <a:t>1/27/13</a:t>
             </a:fld>
             <a:endParaRPr lang="en-US"/>
@@ -1815,8 +1806,8 @@
           <a:bodyPr/>
           <a:lstStyle/>
           <a:p>
-            <a:fld id="{C1FF6DA9-008F-8B48-92A6-B652298478BF}" type="slidenum">
-              <a:rPr lang="en-US" smtClean="0"/>
+            <a:fld id="{BF533E07-937E-4FED-8300-891295843456}" type="slidenum">
+              <a:rPr lang="en-US"/>
               <a:t>‹#›</a:t>
             </a:fld>
             <a:endParaRPr lang="en-US"/>
@@ -1824,11 +1815,6 @@
         </p:txBody>
       </p:sp>
     </p:spTree>
-    <p:extLst>
-      <p:ext uri="{BB962C8B-B14F-4D97-AF65-F5344CB8AC3E}">
-        <p14:creationId xmlns:p14="http://schemas.microsoft.com/office/powerpoint/2010/main" val="990158736"/>
-      </p:ext>
-    </p:extLst>
   </p:cSld>
   <p:clrMapOvr>
     <a:masterClrMapping/>
@@ -1869,7 +1855,7 @@
           <a:lstStyle/>
           <a:p>
             <a:r>
-              <a:rPr lang="en-US" smtClean="0"/>
+              <a:rPr lang="en-US"/>
               <a:t>Click to edit Master title style</a:t>
             </a:r>
             <a:endParaRPr lang="en-US"/>
@@ -1891,8 +1877,8 @@
           <a:bodyPr/>
           <a:lstStyle/>
           <a:p>
-            <a:fld id="{5BCAD085-E8A6-8845-BD4E-CB4CCA059FC4}" type="datetimeFigureOut">
-              <a:rPr lang="en-US" smtClean="0"/>
+            <a:fld id="{D5CAC346-E4DF-45C0-848B-E2AC5513E0D5}" type="datetimeFigureOut">
+              <a:rPr lang="en-US"/>
               <a:t>1/27/13</a:t>
             </a:fld>
             <a:endParaRPr lang="en-US"/>
@@ -1933,8 +1919,8 @@
           <a:bodyPr/>
           <a:lstStyle/>
           <a:p>
-            <a:fld id="{C1FF6DA9-008F-8B48-92A6-B652298478BF}" type="slidenum">
-              <a:rPr lang="en-US" smtClean="0"/>
+            <a:fld id="{7A28B55B-FA15-48BA-860D-0231187503D9}" type="slidenum">
+              <a:rPr lang="en-US"/>
               <a:t>‹#›</a:t>
             </a:fld>
             <a:endParaRPr lang="en-US"/>
@@ -1942,11 +1928,6 @@
         </p:txBody>
       </p:sp>
     </p:spTree>
-    <p:extLst>
-      <p:ext uri="{BB962C8B-B14F-4D97-AF65-F5344CB8AC3E}">
-        <p14:creationId xmlns:p14="http://schemas.microsoft.com/office/powerpoint/2010/main" val="727027711"/>
-      </p:ext>
-    </p:extLst>
   </p:cSld>
   <p:clrMapOvr>
     <a:masterClrMapping/>
@@ -1986,8 +1967,8 @@
           <a:bodyPr/>
           <a:lstStyle/>
           <a:p>
-            <a:fld id="{5BCAD085-E8A6-8845-BD4E-CB4CCA059FC4}" type="datetimeFigureOut">
-              <a:rPr lang="en-US" smtClean="0"/>
+            <a:fld id="{FE20B29E-DC2A-4D67-887F-3BE2DC8489D6}" type="datetimeFigureOut">
+              <a:rPr lang="en-US"/>
               <a:t>1/27/13</a:t>
             </a:fld>
             <a:endParaRPr lang="en-US"/>
@@ -2028,8 +2009,8 @@
           <a:bodyPr/>
           <a:lstStyle/>
           <a:p>
-            <a:fld id="{C1FF6DA9-008F-8B48-92A6-B652298478BF}" type="slidenum">
-              <a:rPr lang="en-US" smtClean="0"/>
+            <a:fld id="{00E0EBC0-ADA9-4FA7-889C-9287646BC794}" type="slidenum">
+              <a:rPr lang="en-US"/>
               <a:t>‹#›</a:t>
             </a:fld>
             <a:endParaRPr lang="en-US"/>
@@ -2037,11 +2018,6 @@
         </p:txBody>
       </p:sp>
     </p:spTree>
-    <p:extLst>
-      <p:ext uri="{BB962C8B-B14F-4D97-AF65-F5344CB8AC3E}">
-        <p14:creationId xmlns:p14="http://schemas.microsoft.com/office/powerpoint/2010/main" val="1212999818"/>
-      </p:ext>
-    </p:extLst>
   </p:cSld>
   <p:clrMapOvr>
     <a:masterClrMapping/>
@@ -2081,6 +2057,9 @@
             <a:off x="457200" y="273050"/>
             <a:ext cx="3008313" cy="1162050"/>
           </a:xfrm>
+          <a:prstGeom prst="rect">
+            <a:avLst/>
+          </a:prstGeom>
         </p:spPr>
         <p:txBody>
           <a:bodyPr anchor="b"/>
@@ -2091,7 +2070,7 @@
           </a:lstStyle>
           <a:p>
             <a:r>
-              <a:rPr lang="en-US" smtClean="0"/>
+              <a:rPr lang="en-US"/>
               <a:t>Click to edit Master title style</a:t>
             </a:r>
             <a:endParaRPr lang="en-US"/>
@@ -2113,6 +2092,9 @@
             <a:off x="3575050" y="273050"/>
             <a:ext cx="5111750" cy="5853113"/>
           </a:xfrm>
+          <a:prstGeom prst="rect">
+            <a:avLst/>
+          </a:prstGeom>
         </p:spPr>
         <p:txBody>
           <a:bodyPr/>
@@ -2146,37 +2128,36 @@
             </a:lvl9pPr>
           </a:lstStyle>
           <a:p>
-            <a:pPr lvl="0"/>
-            <a:r>
-              <a:rPr lang="en-US" smtClean="0"/>
+            <a:r>
+              <a:rPr lang="en-US"/>
               <a:t>Click to edit Master text styles</a:t>
             </a:r>
           </a:p>
           <a:p>
             <a:pPr lvl="1"/>
             <a:r>
-              <a:rPr lang="en-US" smtClean="0"/>
+              <a:rPr lang="en-US"/>
               <a:t>Second level</a:t>
             </a:r>
           </a:p>
           <a:p>
             <a:pPr lvl="2"/>
             <a:r>
-              <a:rPr lang="en-US" smtClean="0"/>
+              <a:rPr lang="en-US"/>
               <a:t>Third level</a:t>
             </a:r>
           </a:p>
           <a:p>
             <a:pPr lvl="3"/>
             <a:r>
-              <a:rPr lang="en-US" smtClean="0"/>
+              <a:rPr lang="en-US"/>
               <a:t>Fourth level</a:t>
             </a:r>
           </a:p>
           <a:p>
             <a:pPr lvl="4"/>
             <a:r>
-              <a:rPr lang="en-US" smtClean="0"/>
+              <a:rPr lang="en-US"/>
               <a:t>Fifth level</a:t>
             </a:r>
             <a:endParaRPr lang="en-US"/>
@@ -2198,6 +2179,9 @@
             <a:off x="457200" y="1435100"/>
             <a:ext cx="3008313" cy="4691063"/>
           </a:xfrm>
+          <a:prstGeom prst="rect">
+            <a:avLst/>
+          </a:prstGeom>
         </p:spPr>
         <p:txBody>
           <a:bodyPr/>
@@ -2240,9 +2224,8 @@
             </a:lvl9pPr>
           </a:lstStyle>
           <a:p>
-            <a:pPr lvl="0"/>
-            <a:r>
-              <a:rPr lang="en-US" smtClean="0"/>
+            <a:r>
+              <a:rPr lang="en-US"/>
               <a:t>Click to edit Master text styles</a:t>
             </a:r>
           </a:p>
@@ -2263,8 +2246,8 @@
           <a:bodyPr/>
           <a:lstStyle/>
           <a:p>
-            <a:fld id="{5BCAD085-E8A6-8845-BD4E-CB4CCA059FC4}" type="datetimeFigureOut">
-              <a:rPr lang="en-US" smtClean="0"/>
+            <a:fld id="{AFC563BD-7186-488E-816C-8F41FA24179F}" type="datetimeFigureOut">
+              <a:rPr lang="en-US"/>
               <a:t>1/27/13</a:t>
             </a:fld>
             <a:endParaRPr lang="en-US"/>
@@ -2305,8 +2288,8 @@
           <a:bodyPr/>
           <a:lstStyle/>
           <a:p>
-            <a:fld id="{C1FF6DA9-008F-8B48-92A6-B652298478BF}" type="slidenum">
-              <a:rPr lang="en-US" smtClean="0"/>
+            <a:fld id="{7DA25AB8-FB3A-479C-8780-0B7E5F586C0F}" type="slidenum">
+              <a:rPr lang="en-US"/>
               <a:t>‹#›</a:t>
             </a:fld>
             <a:endParaRPr lang="en-US"/>
@@ -2314,11 +2297,6 @@
         </p:txBody>
       </p:sp>
     </p:spTree>
-    <p:extLst>
-      <p:ext uri="{BB962C8B-B14F-4D97-AF65-F5344CB8AC3E}">
-        <p14:creationId xmlns:p14="http://schemas.microsoft.com/office/powerpoint/2010/main" val="1840726560"/>
-      </p:ext>
-    </p:extLst>
   </p:cSld>
   <p:clrMapOvr>
     <a:masterClrMapping/>
@@ -2358,6 +2336,9 @@
             <a:off x="1792288" y="4800600"/>
             <a:ext cx="5486400" cy="566738"/>
           </a:xfrm>
+          <a:prstGeom prst="rect">
+            <a:avLst/>
+          </a:prstGeom>
         </p:spPr>
         <p:txBody>
           <a:bodyPr anchor="b"/>
@@ -2368,7 +2349,7 @@
           </a:lstStyle>
           <a:p>
             <a:r>
-              <a:rPr lang="en-US" smtClean="0"/>
+              <a:rPr lang="en-US"/>
               <a:t>Click to edit Master title style</a:t>
             </a:r>
             <a:endParaRPr lang="en-US"/>
@@ -2390,6 +2371,9 @@
             <a:off x="1792288" y="612775"/>
             <a:ext cx="5486400" cy="4114800"/>
           </a:xfrm>
+          <a:prstGeom prst="rect">
+            <a:avLst/>
+          </a:prstGeom>
         </p:spPr>
         <p:txBody>
           <a:bodyPr/>
@@ -2451,6 +2435,9 @@
             <a:off x="1792288" y="5367338"/>
             <a:ext cx="5486400" cy="804862"/>
           </a:xfrm>
+          <a:prstGeom prst="rect">
+            <a:avLst/>
+          </a:prstGeom>
         </p:spPr>
         <p:txBody>
           <a:bodyPr/>
@@ -2493,9 +2480,8 @@
             </a:lvl9pPr>
           </a:lstStyle>
           <a:p>
-            <a:pPr lvl="0"/>
-            <a:r>
-              <a:rPr lang="en-US" smtClean="0"/>
+            <a:r>
+              <a:rPr lang="en-US"/>
               <a:t>Click to edit Master text styles</a:t>
             </a:r>
           </a:p>
@@ -2516,8 +2502,8 @@
           <a:bodyPr/>
           <a:lstStyle/>
           <a:p>
-            <a:fld id="{5BCAD085-E8A6-8845-BD4E-CB4CCA059FC4}" type="datetimeFigureOut">
-              <a:rPr lang="en-US" smtClean="0"/>
+            <a:fld id="{1EE02C48-70E8-4C8D-81F4-17FB598144B8}" type="datetimeFigureOut">
+              <a:rPr lang="en-US"/>
               <a:t>1/27/13</a:t>
             </a:fld>
             <a:endParaRPr lang="en-US"/>
@@ -2558,8 +2544,8 @@
           <a:bodyPr/>
           <a:lstStyle/>
           <a:p>
-            <a:fld id="{C1FF6DA9-008F-8B48-92A6-B652298478BF}" type="slidenum">
-              <a:rPr lang="en-US" smtClean="0"/>
+            <a:fld id="{5AEFC29A-6C4F-4141-86E3-1A3E2D58E3A2}" type="slidenum">
+              <a:rPr lang="en-US"/>
               <a:t>‹#›</a:t>
             </a:fld>
             <a:endParaRPr lang="en-US"/>
@@ -2567,11 +2553,6 @@
         </p:txBody>
       </p:sp>
     </p:spTree>
-    <p:extLst>
-      <p:ext uri="{BB962C8B-B14F-4D97-AF65-F5344CB8AC3E}">
-        <p14:creationId xmlns:p14="http://schemas.microsoft.com/office/powerpoint/2010/main" val="3889236939"/>
-      </p:ext>
-    </p:extLst>
   </p:cSld>
   <p:clrMapOvr>
     <a:masterClrMapping/>
@@ -2581,7 +2562,7 @@
 
 <file path=ppt/slideMasters/slideMaster1.xml><?xml version="1.0" encoding="utf-8"?>
 <p:sldMaster xmlns:a="http://schemas.openxmlformats.org/drawingml/2006/main" xmlns:r="http://schemas.openxmlformats.org/officeDocument/2006/relationships" xmlns:p="http://schemas.openxmlformats.org/presentationml/2006/main">
-  <p:cSld>
+  <p:cSld name="Office Theme">
     <p:bg>
       <p:bgRef idx="1001">
         <a:schemeClr val="bg1"/>
@@ -2627,7 +2608,7 @@
           <a:lstStyle/>
           <a:p>
             <a:r>
-              <a:rPr lang="en-US" smtClean="0"/>
+              <a:rPr lang="en-US"/>
               <a:t>Click to edit Master title style</a:t>
             </a:r>
             <a:endParaRPr lang="en-US"/>
@@ -2659,37 +2640,36 @@
           </a:bodyPr>
           <a:lstStyle/>
           <a:p>
-            <a:pPr lvl="0"/>
-            <a:r>
-              <a:rPr lang="en-US" smtClean="0"/>
+            <a:r>
+              <a:rPr lang="en-US"/>
               <a:t>Click to edit Master text styles</a:t>
             </a:r>
           </a:p>
           <a:p>
             <a:pPr lvl="1"/>
             <a:r>
-              <a:rPr lang="en-US" smtClean="0"/>
+              <a:rPr lang="en-US"/>
               <a:t>Second level</a:t>
             </a:r>
           </a:p>
           <a:p>
             <a:pPr lvl="2"/>
             <a:r>
-              <a:rPr lang="en-US" smtClean="0"/>
+              <a:rPr lang="en-US"/>
               <a:t>Third level</a:t>
             </a:r>
           </a:p>
           <a:p>
             <a:pPr lvl="3"/>
             <a:r>
-              <a:rPr lang="en-US" smtClean="0"/>
+              <a:rPr lang="en-US"/>
               <a:t>Fourth level</a:t>
             </a:r>
           </a:p>
           <a:p>
             <a:pPr lvl="4"/>
             <a:r>
-              <a:rPr lang="en-US" smtClean="0"/>
+              <a:rPr lang="en-US"/>
               <a:t>Fifth level</a:t>
             </a:r>
             <a:endParaRPr lang="en-US"/>
@@ -2729,8 +2709,8 @@
             </a:lvl1pPr>
           </a:lstStyle>
           <a:p>
-            <a:fld id="{5BCAD085-E8A6-8845-BD4E-CB4CCA059FC4}" type="datetimeFigureOut">
-              <a:rPr lang="en-US" smtClean="0"/>
+            <a:fld id="{90ADADCF-DC63-475D-8D69-AEBF4EDF3BBC}" type="datetimeFigureOut">
+              <a:rPr lang="en-US"/>
               <a:t>1/27/13</a:t>
             </a:fld>
             <a:endParaRPr lang="en-US"/>
@@ -2807,8 +2787,8 @@
             </a:lvl1pPr>
           </a:lstStyle>
           <a:p>
-            <a:fld id="{C1FF6DA9-008F-8B48-92A6-B652298478BF}" type="slidenum">
-              <a:rPr lang="en-US" smtClean="0"/>
+            <a:fld id="{473D6AB1-0FDA-49F1-8390-8828CE9E6676}" type="slidenum">
+              <a:rPr lang="en-US"/>
               <a:t>‹#›</a:t>
             </a:fld>
             <a:endParaRPr lang="en-US"/>
@@ -2816,11 +2796,6 @@
         </p:txBody>
       </p:sp>
     </p:spTree>
-    <p:extLst>
-      <p:ext uri="{BB962C8B-B14F-4D97-AF65-F5344CB8AC3E}">
-        <p14:creationId xmlns:p14="http://schemas.microsoft.com/office/powerpoint/2010/main" val="2209977519"/>
-      </p:ext>
-    </p:extLst>
   </p:cSld>
   <p:clrMap bg1="lt1" tx1="dk1" bg2="lt2" tx2="dk2" accent1="accent1" accent2="accent2" accent3="accent3" accent4="accent4" accent5="accent5" accent6="accent6" hlink="hlink" folHlink="folHlink"/>
   <p:sldLayoutIdLst>
@@ -2838,7 +2813,7 @@
   </p:sldLayoutIdLst>
   <p:txStyles>
     <p:titleStyle>
-      <a:lvl1pPr algn="ctr" defTabSz="457200" rtl="0" eaLnBrk="1" latinLnBrk="0" hangingPunct="1">
+      <a:lvl1pPr algn="ctr" defTabSz="457200" rtl="0" eaLnBrk="1">
         <a:spcBef>
           <a:spcPct val="0"/>
         </a:spcBef>
@@ -2854,7 +2829,7 @@
       </a:lvl1pPr>
     </p:titleStyle>
     <p:bodyStyle>
-      <a:lvl1pPr marL="342900" indent="-342900" algn="l" defTabSz="457200" rtl="0" eaLnBrk="1" latinLnBrk="0" hangingPunct="1">
+      <a:lvl1pPr marL="342900" indent="-342900" algn="l" defTabSz="457200" rtl="0" eaLnBrk="1">
         <a:spcBef>
           <a:spcPct val="20000"/>
         </a:spcBef>
@@ -2869,7 +2844,7 @@
           <a:cs typeface="+mn-cs"/>
         </a:defRPr>
       </a:lvl1pPr>
-      <a:lvl2pPr marL="742950" indent="-285750" algn="l" defTabSz="457200" rtl="0" eaLnBrk="1" latinLnBrk="0" hangingPunct="1">
+      <a:lvl2pPr marL="742950" indent="-285750" algn="l" defTabSz="457200" rtl="0" eaLnBrk="1">
         <a:spcBef>
           <a:spcPct val="20000"/>
         </a:spcBef>
@@ -2884,7 +2859,7 @@
           <a:cs typeface="+mn-cs"/>
         </a:defRPr>
       </a:lvl2pPr>
-      <a:lvl3pPr marL="1143000" indent="-228600" algn="l" defTabSz="457200" rtl="0" eaLnBrk="1" latinLnBrk="0" hangingPunct="1">
+      <a:lvl3pPr marL="1143000" indent="-228600" algn="l" defTabSz="457200" rtl="0" eaLnBrk="1">
         <a:spcBef>
           <a:spcPct val="20000"/>
         </a:spcBef>
@@ -2899,7 +2874,7 @@
           <a:cs typeface="+mn-cs"/>
         </a:defRPr>
       </a:lvl3pPr>
-      <a:lvl4pPr marL="1600200" indent="-228600" algn="l" defTabSz="457200" rtl="0" eaLnBrk="1" latinLnBrk="0" hangingPunct="1">
+      <a:lvl4pPr marL="1600200" indent="-228600" algn="l" defTabSz="457200" rtl="0" eaLnBrk="1">
         <a:spcBef>
           <a:spcPct val="20000"/>
         </a:spcBef>
@@ -2914,7 +2889,7 @@
           <a:cs typeface="+mn-cs"/>
         </a:defRPr>
       </a:lvl4pPr>
-      <a:lvl5pPr marL="2057400" indent="-228600" algn="l" defTabSz="457200" rtl="0" eaLnBrk="1" latinLnBrk="0" hangingPunct="1">
+      <a:lvl5pPr marL="2057400" indent="-228600" algn="l" defTabSz="457200" rtl="0" eaLnBrk="1">
         <a:spcBef>
           <a:spcPct val="20000"/>
         </a:spcBef>
@@ -2929,7 +2904,7 @@
           <a:cs typeface="+mn-cs"/>
         </a:defRPr>
       </a:lvl5pPr>
-      <a:lvl6pPr marL="2514600" indent="-228600" algn="l" defTabSz="457200" rtl="0" eaLnBrk="1" latinLnBrk="0" hangingPunct="1">
+      <a:lvl6pPr marL="2514600" indent="-228600" algn="l" defTabSz="457200" rtl="0" eaLnBrk="1">
         <a:spcBef>
           <a:spcPct val="20000"/>
         </a:spcBef>
@@ -2944,7 +2919,7 @@
           <a:cs typeface="+mn-cs"/>
         </a:defRPr>
       </a:lvl6pPr>
-      <a:lvl7pPr marL="2971800" indent="-228600" algn="l" defTabSz="457200" rtl="0" eaLnBrk="1" latinLnBrk="0" hangingPunct="1">
+      <a:lvl7pPr marL="2971800" indent="-228600" algn="l" defTabSz="457200" rtl="0" eaLnBrk="1">
         <a:spcBef>
           <a:spcPct val="20000"/>
         </a:spcBef>
@@ -2959,7 +2934,7 @@
           <a:cs typeface="+mn-cs"/>
         </a:defRPr>
       </a:lvl7pPr>
-      <a:lvl8pPr marL="3429000" indent="-228600" algn="l" defTabSz="457200" rtl="0" eaLnBrk="1" latinLnBrk="0" hangingPunct="1">
+      <a:lvl8pPr marL="3429000" indent="-228600" algn="l" defTabSz="457200" rtl="0" eaLnBrk="1">
         <a:spcBef>
           <a:spcPct val="20000"/>
         </a:spcBef>
@@ -2974,7 +2949,7 @@
           <a:cs typeface="+mn-cs"/>
         </a:defRPr>
       </a:lvl8pPr>
-      <a:lvl9pPr marL="3886200" indent="-228600" algn="l" defTabSz="457200" rtl="0" eaLnBrk="1" latinLnBrk="0" hangingPunct="1">
+      <a:lvl9pPr marL="3886200" indent="-228600" algn="l" defTabSz="457200" rtl="0" eaLnBrk="1">
         <a:spcBef>
           <a:spcPct val="20000"/>
         </a:spcBef>
@@ -2991,10 +2966,7 @@
       </a:lvl9pPr>
     </p:bodyStyle>
     <p:otherStyle>
-      <a:defPPr>
-        <a:defRPr lang="en-US"/>
-      </a:defPPr>
-      <a:lvl1pPr marL="0" algn="l" defTabSz="457200" rtl="0" eaLnBrk="1" latinLnBrk="0" hangingPunct="1">
+      <a:lvl1pPr marL="0" algn="l" defTabSz="457200" rtl="0" eaLnBrk="1">
         <a:defRPr sz="1800" kern="1200">
           <a:solidFill>
             <a:schemeClr val="tx1"/>
@@ -3004,7 +2976,7 @@
           <a:cs typeface="+mn-cs"/>
         </a:defRPr>
       </a:lvl1pPr>
-      <a:lvl2pPr marL="457200" algn="l" defTabSz="457200" rtl="0" eaLnBrk="1" latinLnBrk="0" hangingPunct="1">
+      <a:lvl2pPr marL="457200" algn="l" defTabSz="457200" rtl="0" eaLnBrk="1">
         <a:defRPr sz="1800" kern="1200">
           <a:solidFill>
             <a:schemeClr val="tx1"/>
@@ -3014,7 +2986,7 @@
           <a:cs typeface="+mn-cs"/>
         </a:defRPr>
       </a:lvl2pPr>
-      <a:lvl3pPr marL="914400" algn="l" defTabSz="457200" rtl="0" eaLnBrk="1" latinLnBrk="0" hangingPunct="1">
+      <a:lvl3pPr marL="914400" algn="l" defTabSz="457200" rtl="0" eaLnBrk="1">
         <a:defRPr sz="1800" kern="1200">
           <a:solidFill>
             <a:schemeClr val="tx1"/>
@@ -3024,7 +2996,7 @@
           <a:cs typeface="+mn-cs"/>
         </a:defRPr>
       </a:lvl3pPr>
-      <a:lvl4pPr marL="1371600" algn="l" defTabSz="457200" rtl="0" eaLnBrk="1" latinLnBrk="0" hangingPunct="1">
+      <a:lvl4pPr marL="1371600" algn="l" defTabSz="457200" rtl="0" eaLnBrk="1">
         <a:defRPr sz="1800" kern="1200">
           <a:solidFill>
             <a:schemeClr val="tx1"/>
@@ -3034,7 +3006,7 @@
           <a:cs typeface="+mn-cs"/>
         </a:defRPr>
       </a:lvl4pPr>
-      <a:lvl5pPr marL="1828800" algn="l" defTabSz="457200" rtl="0" eaLnBrk="1" latinLnBrk="0" hangingPunct="1">
+      <a:lvl5pPr marL="1828800" algn="l" defTabSz="457200" rtl="0" eaLnBrk="1">
         <a:defRPr sz="1800" kern="1200">
           <a:solidFill>
             <a:schemeClr val="tx1"/>
@@ -3044,7 +3016,7 @@
           <a:cs typeface="+mn-cs"/>
         </a:defRPr>
       </a:lvl5pPr>
-      <a:lvl6pPr marL="2286000" algn="l" defTabSz="457200" rtl="0" eaLnBrk="1" latinLnBrk="0" hangingPunct="1">
+      <a:lvl6pPr marL="2286000" algn="l" defTabSz="457200" rtl="0" eaLnBrk="1">
         <a:defRPr sz="1800" kern="1200">
           <a:solidFill>
             <a:schemeClr val="tx1"/>
@@ -3054,7 +3026,7 @@
           <a:cs typeface="+mn-cs"/>
         </a:defRPr>
       </a:lvl6pPr>
-      <a:lvl7pPr marL="2743200" algn="l" defTabSz="457200" rtl="0" eaLnBrk="1" latinLnBrk="0" hangingPunct="1">
+      <a:lvl7pPr marL="2743200" algn="l" defTabSz="457200" rtl="0" eaLnBrk="1">
         <a:defRPr sz="1800" kern="1200">
           <a:solidFill>
             <a:schemeClr val="tx1"/>
@@ -3064,7 +3036,7 @@
           <a:cs typeface="+mn-cs"/>
         </a:defRPr>
       </a:lvl7pPr>
-      <a:lvl8pPr marL="3200400" algn="l" defTabSz="457200" rtl="0" eaLnBrk="1" latinLnBrk="0" hangingPunct="1">
+      <a:lvl8pPr marL="3200400" algn="l" defTabSz="457200" rtl="0" eaLnBrk="1">
         <a:defRPr sz="1800" kern="1200">
           <a:solidFill>
             <a:schemeClr val="tx1"/>
@@ -3074,7 +3046,7 @@
           <a:cs typeface="+mn-cs"/>
         </a:defRPr>
       </a:lvl8pPr>
-      <a:lvl9pPr marL="3657600" algn="l" defTabSz="457200" rtl="0" eaLnBrk="1" latinLnBrk="0" hangingPunct="1">
+      <a:lvl9pPr marL="3657600" algn="l" defTabSz="457200" rtl="0" eaLnBrk="1">
         <a:defRPr sz="1800" kern="1200">
           <a:solidFill>
             <a:schemeClr val="tx1"/>
@@ -3090,7 +3062,7 @@
 </file>
 
 <file path=ppt/slides/slide1.xml><?xml version="1.0" encoding="utf-8"?>
-<p:sld xmlns:a="http://schemas.openxmlformats.org/drawingml/2006/main" xmlns:p="http://schemas.openxmlformats.org/presentationml/2006/main" xmlns:r="http://schemas.openxmlformats.org/officeDocument/2006/relationships">
+<p:sld xmlns:a="http://schemas.openxmlformats.org/drawingml/2006/main" xmlns:r="http://schemas.openxmlformats.org/officeDocument/2006/relationships" xmlns:p="http://schemas.openxmlformats.org/presentationml/2006/main">
   <p:cSld>
     <p:spTree>
       <p:nvGrpSpPr>
@@ -3098,7 +3070,14 @@
         <p:cNvGrpSpPr/>
         <p:nvPr/>
       </p:nvGrpSpPr>
-      <p:grpSpPr/>
+      <p:grpSpPr>
+        <a:xfrm>
+          <a:off x="0" y="0"/>
+          <a:ext cx="0" cy="0"/>
+          <a:chOff x="0" y="0"/>
+          <a:chExt cx="0" cy="0"/>
+        </a:xfrm>
+      </p:grpSpPr>
       <p:sp>
         <p:nvSpPr>
           <p:cNvPr id="2" name="TextBox 1"/>
@@ -3191,13 +3170,9 @@
               <a:spcAft>
                 <a:spcPts val="400"/>
               </a:spcAft>
-              <a:defRPr sz="1800">
-                <a:solidFill>
-                  <a:srgbClr val="222222"/>
-                </a:solidFill>
-              </a:defRPr>
             </a:pPr>
             <a:r>
+              <a:rPr/>
               <a:t>Windows desktop application for audio capture, enhancement, comparison, evaluation, and report generation.</a:t>
             </a:r>
           </a:p>
@@ -3206,13 +3181,9 @@
               <a:spcAft>
                 <a:spcPts val="400"/>
               </a:spcAft>
-              <a:defRPr sz="1800">
-                <a:solidFill>
-                  <a:srgbClr val="222222"/>
-                </a:solidFill>
-              </a:defRPr>
             </a:pPr>
             <a:r>
+              <a:rPr/>
               <a:t>Implemented with Python, PySide6, NumPy, SciPy, ONNX Runtime, sounddevice, and matplotlib.</a:t>
             </a:r>
           </a:p>
@@ -3221,13 +3192,9 @@
               <a:spcAft>
                 <a:spcPts val="400"/>
               </a:spcAft>
-              <a:defRPr sz="1800">
-                <a:solidFill>
-                  <a:srgbClr val="222222"/>
-                </a:solidFill>
-              </a:defRPr>
             </a:pPr>
             <a:r>
+              <a:rPr/>
               <a:t>Mode support: DSP, ML-enhanced, and hybrid ML-followed-by-DSP processing.</a:t>
             </a:r>
           </a:p>
@@ -3236,13 +3203,9 @@
               <a:spcAft>
                 <a:spcPts val="400"/>
               </a:spcAft>
-              <a:defRPr sz="1800">
-                <a:solidFill>
-                  <a:srgbClr val="222222"/>
-                </a:solidFill>
-              </a:defRPr>
             </a:pPr>
             <a:r>
+              <a:rPr/>
               <a:t>Academic fields shown as placeholders for names, roll numbers, institution, department, guide, and academic year.</a:t>
             </a:r>
           </a:p>
@@ -3274,13 +3237,9 @@
               <a:spcAft>
                 <a:spcPts val="400"/>
               </a:spcAft>
-              <a:defRPr sz="1400">
-                <a:solidFill>
-                  <a:srgbClr val="222222"/>
-                </a:solidFill>
-              </a:defRPr>
             </a:pPr>
             <a:r>
+              <a:rPr/>
               <a:t>Prepared for project review. Evidence is taken from the current workspace: source code, tests, evaluation results, plots, and build output.</a:t>
             </a:r>
           </a:p>
@@ -3328,7 +3287,7 @@
 </file>
 
 <file path=ppt/slides/slide10.xml><?xml version="1.0" encoding="utf-8"?>
-<p:sld xmlns:a="http://schemas.openxmlformats.org/drawingml/2006/main" xmlns:p="http://schemas.openxmlformats.org/presentationml/2006/main" xmlns:r="http://schemas.openxmlformats.org/officeDocument/2006/relationships">
+<p:sld xmlns:a="http://schemas.openxmlformats.org/drawingml/2006/main" xmlns:r="http://schemas.openxmlformats.org/officeDocument/2006/relationships" xmlns:p="http://schemas.openxmlformats.org/presentationml/2006/main">
   <p:cSld>
     <p:spTree>
       <p:nvGrpSpPr>
@@ -3336,7 +3295,14 @@
         <p:cNvGrpSpPr/>
         <p:nvPr/>
       </p:nvGrpSpPr>
-      <p:grpSpPr/>
+      <p:grpSpPr>
+        <a:xfrm>
+          <a:off x="0" y="0"/>
+          <a:ext cx="0" cy="0"/>
+          <a:chOff x="0" y="0"/>
+          <a:chExt cx="0" cy="0"/>
+        </a:xfrm>
+      </p:grpSpPr>
       <p:sp>
         <p:nvSpPr>
           <p:cNvPr id="2" name="TextBox 1"/>
@@ -3726,7 +3692,7 @@
 </file>
 
 <file path=ppt/slides/slide11.xml><?xml version="1.0" encoding="utf-8"?>
-<p:sld xmlns:a="http://schemas.openxmlformats.org/drawingml/2006/main" xmlns:p="http://schemas.openxmlformats.org/presentationml/2006/main" xmlns:r="http://schemas.openxmlformats.org/officeDocument/2006/relationships">
+<p:sld xmlns:a="http://schemas.openxmlformats.org/drawingml/2006/main" xmlns:r="http://schemas.openxmlformats.org/officeDocument/2006/relationships" xmlns:p="http://schemas.openxmlformats.org/presentationml/2006/main">
   <p:cSld>
     <p:spTree>
       <p:nvGrpSpPr>
@@ -3734,7 +3700,14 @@
         <p:cNvGrpSpPr/>
         <p:nvPr/>
       </p:nvGrpSpPr>
-      <p:grpSpPr/>
+      <p:grpSpPr>
+        <a:xfrm>
+          <a:off x="0" y="0"/>
+          <a:ext cx="0" cy="0"/>
+          <a:chOff x="0" y="0"/>
+          <a:chExt cx="0" cy="0"/>
+        </a:xfrm>
+      </p:grpSpPr>
       <p:sp>
         <p:nvSpPr>
           <p:cNvPr id="2" name="TextBox 1"/>
@@ -3794,13 +3767,9 @@
               <a:spcAft>
                 <a:spcPts val="400"/>
               </a:spcAft>
-              <a:defRPr sz="1600">
-                <a:solidFill>
-                  <a:srgbClr val="222222"/>
-                </a:solidFill>
-              </a:defRPr>
             </a:pPr>
             <a:r>
+              <a:rPr/>
               <a:t>Physical microphone quality, room noise, acoustic feedback, and speaker use are not validated here.</a:t>
             </a:r>
           </a:p>
@@ -3809,13 +3778,9 @@
               <a:spcAft>
                 <a:spcPts val="400"/>
               </a:spcAft>
-              <a:defRPr sz="1600">
-                <a:solidFill>
-                  <a:srgbClr val="222222"/>
-                </a:solidFill>
-              </a:defRPr>
             </a:pPr>
             <a:r>
+              <a:rPr/>
               <a:t>No software acoustic echo cancellation is implemented; headphones are recommended for monitoring.</a:t>
             </a:r>
           </a:p>
@@ -3824,13 +3789,9 @@
               <a:spcAft>
                 <a:spcPts val="400"/>
               </a:spcAft>
-              <a:defRPr sz="1600">
-                <a:solidFill>
-                  <a:srgbClr val="222222"/>
-                </a:solidFill>
-              </a:defRPr>
             </a:pPr>
             <a:r>
+              <a:rPr/>
               <a:t>ML and hybrid enhancement use buffered chunks and introduce latency.</a:t>
             </a:r>
           </a:p>
@@ -3839,13 +3800,9 @@
               <a:spcAft>
                 <a:spcPts val="400"/>
               </a:spcAft>
-              <a:defRPr sz="1600">
-                <a:solidFill>
-                  <a:srgbClr val="222222"/>
-                </a:solidFill>
-              </a:defRPr>
             </a:pPr>
             <a:r>
+              <a:rPr/>
               <a:t>Only synthetic speech with white, babble, and changing noise was used for reported SNR comparisons.</a:t>
             </a:r>
           </a:p>
@@ -3854,13 +3811,9 @@
               <a:spcAft>
                 <a:spcPts val="400"/>
               </a:spcAft>
-              <a:defRPr sz="1600">
-                <a:solidFill>
-                  <a:srgbClr val="222222"/>
-                </a:solidFill>
-              </a:defRPr>
             </a:pPr>
             <a:r>
+              <a:rPr/>
               <a:t>PESQ/STOI are available only when optional dependencies are installed.</a:t>
             </a:r>
           </a:p>
@@ -3869,13 +3822,9 @@
               <a:spcAft>
                 <a:spcPts val="400"/>
               </a:spcAft>
-              <a:defRPr sz="1600">
-                <a:solidFill>
-                  <a:srgbClr val="222222"/>
-                </a:solidFill>
-              </a:defRPr>
             </a:pPr>
             <a:r>
+              <a:rPr/>
               <a:t>Future work: better speech preservation, reliable real-time processing, thorough ML/hybrid evaluation, virtual-microphone verification, stable packaging, and automated tests.</a:t>
             </a:r>
           </a:p>
@@ -3923,7 +3872,7 @@
 </file>
 
 <file path=ppt/slides/slide12.xml><?xml version="1.0" encoding="utf-8"?>
-<p:sld xmlns:a="http://schemas.openxmlformats.org/drawingml/2006/main" xmlns:p="http://schemas.openxmlformats.org/presentationml/2006/main" xmlns:r="http://schemas.openxmlformats.org/officeDocument/2006/relationships">
+<p:sld xmlns:a="http://schemas.openxmlformats.org/drawingml/2006/main" xmlns:r="http://schemas.openxmlformats.org/officeDocument/2006/relationships" xmlns:p="http://schemas.openxmlformats.org/presentationml/2006/main">
   <p:cSld>
     <p:spTree>
       <p:nvGrpSpPr>
@@ -3931,7 +3880,14 @@
         <p:cNvGrpSpPr/>
         <p:nvPr/>
       </p:nvGrpSpPr>
-      <p:grpSpPr/>
+      <p:grpSpPr>
+        <a:xfrm>
+          <a:off x="0" y="0"/>
+          <a:ext cx="0" cy="0"/>
+          <a:chOff x="0" y="0"/>
+          <a:chExt cx="0" cy="0"/>
+        </a:xfrm>
+      </p:grpSpPr>
       <p:sp>
         <p:nvSpPr>
           <p:cNvPr id="2" name="TextBox 1"/>
@@ -3991,13 +3947,9 @@
               <a:spcAft>
                 <a:spcPts val="400"/>
               </a:spcAft>
-              <a:defRPr sz="1600">
-                <a:solidFill>
-                  <a:srgbClr val="222222"/>
-                </a:solidFill>
-              </a:defRPr>
             </a:pPr>
             <a:r>
+              <a:rPr/>
               <a:t>The project addresses speech enhancement in noisy environments using DSP, V3 ONNX ML, and Hybrid processing.</a:t>
             </a:r>
           </a:p>
@@ -4006,13 +3958,9 @@
               <a:spcAft>
                 <a:spcPts val="400"/>
               </a:spcAft>
-              <a:defRPr sz="1600">
-                <a:solidFill>
-                  <a:srgbClr val="222222"/>
-                </a:solidFill>
-              </a:defRPr>
             </a:pPr>
             <a:r>
+              <a:rPr/>
               <a:t>It includes a PySide6 GUI, offline comparison, metrics, reports, and virtual-microphone routing.</a:t>
             </a:r>
           </a:p>
@@ -4021,13 +3969,9 @@
               <a:spcAft>
                 <a:spcPts val="400"/>
               </a:spcAft>
-              <a:defRPr sz="1600">
-                <a:solidFill>
-                  <a:srgbClr val="222222"/>
-                </a:solidFill>
-              </a:defRPr>
             </a:pPr>
             <a:r>
+              <a:rPr/>
               <a:t>Available evidence shows synthetic-data SNR improvements and fast DSP runtime, but not full physical or meeting-app validation.</a:t>
             </a:r>
           </a:p>
@@ -4036,13 +3980,9 @@
               <a:spcAft>
                 <a:spcPts val="400"/>
               </a:spcAft>
-              <a:defRPr sz="1600">
-                <a:solidFill>
-                  <a:srgbClr val="222222"/>
-                </a:solidFill>
-              </a:defRPr>
             </a:pPr>
             <a:r>
+              <a:rPr/>
               <a:t>The most important remaining work is acoustic/physical testing and verification of meeting software routing.</a:t>
             </a:r>
           </a:p>
@@ -4051,13 +3991,9 @@
               <a:spcAft>
                 <a:spcPts val="400"/>
               </a:spcAft>
-              <a:defRPr sz="1600">
-                <a:solidFill>
-                  <a:srgbClr val="222222"/>
-                </a:solidFill>
-              </a:defRPr>
             </a:pPr>
             <a:r>
+              <a:rPr/>
               <a:t>Thank You / Questions</a:t>
             </a:r>
           </a:p>
@@ -4105,7 +4041,7 @@
 </file>
 
 <file path=ppt/slides/slide2.xml><?xml version="1.0" encoding="utf-8"?>
-<p:sld xmlns:a="http://schemas.openxmlformats.org/drawingml/2006/main" xmlns:p="http://schemas.openxmlformats.org/presentationml/2006/main" xmlns:r="http://schemas.openxmlformats.org/officeDocument/2006/relationships">
+<p:sld xmlns:a="http://schemas.openxmlformats.org/drawingml/2006/main" xmlns:r="http://schemas.openxmlformats.org/officeDocument/2006/relationships" xmlns:p="http://schemas.openxmlformats.org/presentationml/2006/main">
   <p:cSld>
     <p:spTree>
       <p:nvGrpSpPr>
@@ -4113,7 +4049,14 @@
         <p:cNvGrpSpPr/>
         <p:nvPr/>
       </p:nvGrpSpPr>
-      <p:grpSpPr/>
+      <p:grpSpPr>
+        <a:xfrm>
+          <a:off x="0" y="0"/>
+          <a:ext cx="0" cy="0"/>
+          <a:chOff x="0" y="0"/>
+          <a:chExt cx="0" cy="0"/>
+        </a:xfrm>
+      </p:grpSpPr>
       <p:sp>
         <p:nvSpPr>
           <p:cNvPr id="2" name="TextBox 1"/>
@@ -4173,13 +4116,9 @@
               <a:spcAft>
                 <a:spcPts val="400"/>
               </a:spcAft>
-              <a:defRPr sz="1700">
-                <a:solidFill>
-                  <a:srgbClr val="222222"/>
-                </a:solidFill>
-              </a:defRPr>
             </a:pPr>
             <a:r>
+              <a:rPr/>
               <a:t>Background noise reduces speech clarity in recorded and live audio.</a:t>
             </a:r>
           </a:p>
@@ -4188,13 +4127,9 @@
               <a:spcAft>
                 <a:spcPts val="400"/>
               </a:spcAft>
-              <a:defRPr sz="1700">
-                <a:solidFill>
-                  <a:srgbClr val="222222"/>
-                </a:solidFill>
-              </a:defRPr>
             </a:pPr>
             <a:r>
+              <a:rPr/>
               <a:t>Noise reduction must suppress noise while preserving speech; over-suppression can create distortion, pumping, ringing, or robotic artifacts.</a:t>
             </a:r>
           </a:p>
@@ -4203,13 +4138,9 @@
               <a:spcAft>
                 <a:spcPts val="400"/>
               </a:spcAft>
-              <a:defRPr sz="1700">
-                <a:solidFill>
-                  <a:srgbClr val="222222"/>
-                </a:solidFill>
-              </a:defRPr>
             </a:pPr>
             <a:r>
+              <a:rPr/>
               <a:t>Real-time software must avoid feedback loops, bounded-buffer overruns, and missed audio callbacks.</a:t>
             </a:r>
           </a:p>
@@ -4218,13 +4149,9 @@
               <a:spcAft>
                 <a:spcPts val="400"/>
               </a:spcAft>
-              <a:defRPr sz="1700">
-                <a:solidFill>
-                  <a:srgbClr val="222222"/>
-                </a:solidFill>
-              </a:defRPr>
             </a:pPr>
             <a:r>
+              <a:rPr/>
               <a:t>Objectives:</a:t>
             </a:r>
           </a:p>
@@ -4233,13 +4160,9 @@
               <a:spcAft>
                 <a:spcPts val="400"/>
               </a:spcAft>
-              <a:defRPr sz="1700">
-                <a:solidFill>
-                  <a:srgbClr val="222222"/>
-                </a:solidFill>
-              </a:defRPr>
             </a:pPr>
             <a:r>
+              <a:rPr/>
               <a:t>  • Capture microphone audio and support configurable devices.</a:t>
             </a:r>
           </a:p>
@@ -4248,13 +4171,9 @@
               <a:spcAft>
                 <a:spcPts val="400"/>
               </a:spcAft>
-              <a:defRPr sz="1700">
-                <a:solidFill>
-                  <a:srgbClr val="222222"/>
-                </a:solidFill>
-              </a:defRPr>
             </a:pPr>
             <a:r>
+              <a:rPr/>
               <a:t>  • Implement DSP, ML, and hybrid enhancement methods.</a:t>
             </a:r>
           </a:p>
@@ -4263,13 +4182,9 @@
               <a:spcAft>
                 <a:spcPts val="400"/>
               </a:spcAft>
-              <a:defRPr sz="1700">
-                <a:solidFill>
-                  <a:srgbClr val="222222"/>
-                </a:solidFill>
-              </a:defRPr>
             </a:pPr>
             <a:r>
+              <a:rPr/>
               <a:t>  • Compare methods using the same input audio.</a:t>
             </a:r>
           </a:p>
@@ -4278,13 +4193,9 @@
               <a:spcAft>
                 <a:spcPts val="400"/>
               </a:spcAft>
-              <a:defRPr sz="1700">
-                <a:solidFill>
-                  <a:srgbClr val="222222"/>
-                </a:solidFill>
-              </a:defRPr>
             </a:pPr>
             <a:r>
+              <a:rPr/>
               <a:t>  • Generate RMS, peak, SNR, RTF, plots, metrics, and PDF reports where available.</a:t>
             </a:r>
           </a:p>
@@ -4293,13 +4204,9 @@
               <a:spcAft>
                 <a:spcPts val="400"/>
               </a:spcAft>
-              <a:defRPr sz="1700">
-                <a:solidFill>
-                  <a:srgbClr val="222222"/>
-                </a:solidFill>
-              </a:defRPr>
             </a:pPr>
             <a:r>
+              <a:rPr/>
               <a:t>  • Route enhanced speech to a virtual microphone for meeting applications without using physical speakers by default.</a:t>
             </a:r>
           </a:p>
@@ -4347,7 +4254,7 @@
 </file>
 
 <file path=ppt/slides/slide3.xml><?xml version="1.0" encoding="utf-8"?>
-<p:sld xmlns:a="http://schemas.openxmlformats.org/drawingml/2006/main" xmlns:p="http://schemas.openxmlformats.org/presentationml/2006/main" xmlns:r="http://schemas.openxmlformats.org/officeDocument/2006/relationships">
+<p:sld xmlns:a="http://schemas.openxmlformats.org/drawingml/2006/main" xmlns:r="http://schemas.openxmlformats.org/officeDocument/2006/relationships" xmlns:p="http://schemas.openxmlformats.org/presentationml/2006/main">
   <p:cSld>
     <p:spTree>
       <p:nvGrpSpPr>
@@ -4355,7 +4262,14 @@
         <p:cNvGrpSpPr/>
         <p:nvPr/>
       </p:nvGrpSpPr>
-      <p:grpSpPr/>
+      <p:grpSpPr>
+        <a:xfrm>
+          <a:off x="0" y="0"/>
+          <a:ext cx="0" cy="0"/>
+          <a:chOff x="0" y="0"/>
+          <a:chExt cx="0" cy="0"/>
+        </a:xfrm>
+      </p:grpSpPr>
       <p:sp>
         <p:nvSpPr>
           <p:cNvPr id="2" name="TextBox 1"/>
@@ -4733,13 +4647,9 @@
               <a:spcAft>
                 <a:spcPts val="400"/>
               </a:spcAft>
-              <a:defRPr sz="1600">
-                <a:solidFill>
-                  <a:srgbClr val="222222"/>
-                </a:solidFill>
-              </a:defRPr>
             </a:pPr>
             <a:r>
+              <a:rPr/>
               <a:t>Virtual path: enhanced speech -&gt; virtual audio render endpoint -&gt; virtual capture endpoint -&gt; meeting application microphone input.</a:t>
             </a:r>
           </a:p>
@@ -4748,13 +4658,9 @@
               <a:spcAft>
                 <a:spcPts val="400"/>
               </a:spcAft>
-              <a:defRPr sz="1600">
-                <a:solidFill>
-                  <a:srgbClr val="222222"/>
-                </a:solidFill>
-              </a:defRPr>
             </a:pPr>
             <a:r>
+              <a:rPr/>
               <a:t>Physical speakers/headphones are a separate optional monitoring path; they are disabled by default to reduce acoustic feedback.</a:t>
             </a:r>
           </a:p>
@@ -4763,13 +4669,9 @@
               <a:spcAft>
                 <a:spcPts val="400"/>
               </a:spcAft>
-              <a:defRPr sz="1600">
-                <a:solidFill>
-                  <a:srgbClr val="222222"/>
-                </a:solidFill>
-              </a:defRPr>
             </a:pPr>
             <a:r>
+              <a:rPr/>
               <a:t>Implemented in code and tested as software: capture, DSP, ML, hybrid offline, buffering, metrics, reports. Physically unverified: virtual meeting app pairing and acoustic behavior.</a:t>
             </a:r>
           </a:p>
@@ -4817,7 +4719,7 @@
 </file>
 
 <file path=ppt/slides/slide4.xml><?xml version="1.0" encoding="utf-8"?>
-<p:sld xmlns:a="http://schemas.openxmlformats.org/drawingml/2006/main" xmlns:p="http://schemas.openxmlformats.org/presentationml/2006/main" xmlns:r="http://schemas.openxmlformats.org/officeDocument/2006/relationships">
+<p:sld xmlns:a="http://schemas.openxmlformats.org/drawingml/2006/main" xmlns:r="http://schemas.openxmlformats.org/officeDocument/2006/relationships" xmlns:p="http://schemas.openxmlformats.org/presentationml/2006/main">
   <p:cSld>
     <p:spTree>
       <p:nvGrpSpPr>
@@ -4825,7 +4727,14 @@
         <p:cNvGrpSpPr/>
         <p:nvPr/>
       </p:nvGrpSpPr>
-      <p:grpSpPr/>
+      <p:grpSpPr>
+        <a:xfrm>
+          <a:off x="0" y="0"/>
+          <a:ext cx="0" cy="0"/>
+          <a:chOff x="0" y="0"/>
+          <a:chExt cx="0" cy="0"/>
+        </a:xfrm>
+      </p:grpSpPr>
       <p:sp>
         <p:nvSpPr>
           <p:cNvPr id="2" name="TextBox 1"/>
@@ -5115,13 +5024,9 @@
               <a:spcAft>
                 <a:spcPts val="400"/>
               </a:spcAft>
-              <a:defRPr sz="1500">
-                <a:solidFill>
-                  <a:srgbClr val="222222"/>
-                </a:solidFill>
-              </a:defRPr>
             </a:pPr>
             <a:r>
+              <a:rPr/>
               <a:t>Modules: devices.py, engine.py, recording.py, pipeline.py, v41_reducer.py, enhancer.py, workflow.py, metrics.py, main_window.py.</a:t>
             </a:r>
           </a:p>
@@ -5130,13 +5035,9 @@
               <a:spcAft>
                 <a:spcPts val="400"/>
               </a:spcAft>
-              <a:defRPr sz="1500">
-                <a:solidFill>
-                  <a:srgbClr val="222222"/>
-                </a:solidFill>
-              </a:defRPr>
             </a:pPr>
             <a:r>
+              <a:rPr/>
               <a:t>Core runtime flow: configuration -&gt; GUI -&gt; AudioEngine -&gt; InputStream/OutputStream -&gt; processing worker -&gt; EnhancementPipeline / MLEnhancer.</a:t>
             </a:r>
           </a:p>
@@ -5184,7 +5085,7 @@
 </file>
 
 <file path=ppt/slides/slide5.xml><?xml version="1.0" encoding="utf-8"?>
-<p:sld xmlns:a="http://schemas.openxmlformats.org/drawingml/2006/main" xmlns:p="http://schemas.openxmlformats.org/presentationml/2006/main" xmlns:r="http://schemas.openxmlformats.org/officeDocument/2006/relationships">
+<p:sld xmlns:a="http://schemas.openxmlformats.org/drawingml/2006/main" xmlns:r="http://schemas.openxmlformats.org/officeDocument/2006/relationships" xmlns:p="http://schemas.openxmlformats.org/presentationml/2006/main">
   <p:cSld>
     <p:spTree>
       <p:nvGrpSpPr>
@@ -5192,7 +5093,14 @@
         <p:cNvGrpSpPr/>
         <p:nvPr/>
       </p:nvGrpSpPr>
-      <p:grpSpPr/>
+      <p:grpSpPr>
+        <a:xfrm>
+          <a:off x="0" y="0"/>
+          <a:ext cx="0" cy="0"/>
+          <a:chOff x="0" y="0"/>
+          <a:chExt cx="0" cy="0"/>
+        </a:xfrm>
+      </p:grpSpPr>
       <p:sp>
         <p:nvSpPr>
           <p:cNvPr id="2" name="TextBox 1"/>
@@ -5252,13 +5160,9 @@
               <a:spcAft>
                 <a:spcPts val="400"/>
               </a:spcAft>
-              <a:defRPr sz="1600">
-                <a:solidFill>
-                  <a:srgbClr val="222222"/>
-                </a:solidFill>
-              </a:defRPr>
             </a:pPr>
             <a:r>
+              <a:rPr/>
               <a:t>The project includes V4.1 spectral noise reduction, adapted for streaming.</a:t>
             </a:r>
           </a:p>
@@ -5267,13 +5171,9 @@
               <a:spcAft>
                 <a:spcPts val="400"/>
               </a:spcAft>
-              <a:defRPr sz="1600">
-                <a:solidFill>
-                  <a:srgbClr val="222222"/>
-                </a:solidFill>
-              </a:defRPr>
             </a:pPr>
             <a:r>
+              <a:rPr/>
               <a:t>Processing stages: frame/window analysis, noise estimate, speech/noise detection, Wiener gain, gain smoothing, spectral reconstruction, clipping protection.</a:t>
             </a:r>
           </a:p>
@@ -5282,13 +5182,9 @@
               <a:spcAft>
                 <a:spcPts val="400"/>
               </a:spcAft>
-              <a:defRPr sz="1600">
-                <a:solidFill>
-                  <a:srgbClr val="222222"/>
-                </a:solidFill>
-              </a:defRPr>
             </a:pPr>
             <a:r>
+              <a:rPr/>
               <a:t>Noise power and previous gain are maintained as reducer state.</a:t>
             </a:r>
           </a:p>
@@ -5297,13 +5193,9 @@
               <a:spcAft>
                 <a:spcPts val="400"/>
               </a:spcAft>
-              <a:defRPr sz="1600">
-                <a:solidFill>
-                  <a:srgbClr val="222222"/>
-                </a:solidFill>
-              </a:defRPr>
             </a:pPr>
             <a:r>
+              <a:rPr/>
               <a:t>Enhancement strength is controlled by noise reduction and voice preservation parameters.</a:t>
             </a:r>
           </a:p>
@@ -5312,13 +5204,9 @@
               <a:spcAft>
                 <a:spcPts val="400"/>
               </a:spcAft>
-              <a:defRPr sz="1600">
-                <a:solidFill>
-                  <a:srgbClr val="222222"/>
-                </a:solidFill>
-              </a:defRPr>
             </a:pPr>
             <a:r>
+              <a:rPr/>
               <a:t>DSP works on CPU and does not require model inference.</a:t>
             </a:r>
           </a:p>
@@ -5327,13 +5215,9 @@
               <a:spcAft>
                 <a:spcPts val="400"/>
               </a:spcAft>
-              <a:defRPr sz="1600">
-                <a:solidFill>
-                  <a:srgbClr val="222222"/>
-                </a:solidFill>
-              </a:defRPr>
             </a:pPr>
             <a:r>
+              <a:rPr/>
               <a:t>Offline synthetic evaluation reported DSP RTF = 0.0109 for 3.0 seconds of audio.</a:t>
             </a:r>
           </a:p>
@@ -5342,13 +5226,9 @@
               <a:spcAft>
                 <a:spcPts val="400"/>
               </a:spcAft>
-              <a:defRPr sz="1600">
-                <a:solidFill>
-                  <a:srgbClr val="222222"/>
-                </a:solidFill>
-              </a:defRPr>
             </a:pPr>
             <a:r>
+              <a:rPr/>
               <a:t>Limitations: V4.1 is partly utterance-oriented; live processing depends on chunk size, buffer condition, and the quality of the noise estimate.</a:t>
             </a:r>
           </a:p>
@@ -5396,7 +5276,7 @@
 </file>
 
 <file path=ppt/slides/slide6.xml><?xml version="1.0" encoding="utf-8"?>
-<p:sld xmlns:a="http://schemas.openxmlformats.org/drawingml/2006/main" xmlns:p="http://schemas.openxmlformats.org/presentationml/2006/main" xmlns:r="http://schemas.openxmlformats.org/officeDocument/2006/relationships">
+<p:sld xmlns:a="http://schemas.openxmlformats.org/drawingml/2006/main" xmlns:r="http://schemas.openxmlformats.org/officeDocument/2006/relationships" xmlns:p="http://schemas.openxmlformats.org/presentationml/2006/main">
   <p:cSld>
     <p:spTree>
       <p:nvGrpSpPr>
@@ -5404,7 +5284,14 @@
         <p:cNvGrpSpPr/>
         <p:nvPr/>
       </p:nvGrpSpPr>
-      <p:grpSpPr/>
+      <p:grpSpPr>
+        <a:xfrm>
+          <a:off x="0" y="0"/>
+          <a:ext cx="0" cy="0"/>
+          <a:chOff x="0" y="0"/>
+          <a:chExt cx="0" cy="0"/>
+        </a:xfrm>
+      </p:grpSpPr>
       <p:sp>
         <p:nvSpPr>
           <p:cNvPr id="2" name="TextBox 1"/>
@@ -5464,13 +5351,9 @@
               <a:spcAft>
                 <a:spcPts val="400"/>
               </a:spcAft>
-              <a:defRPr sz="1600">
-                <a:solidFill>
-                  <a:srgbClr val="222222"/>
-                </a:solidFill>
-              </a:defRPr>
             </a:pPr>
             <a:r>
+              <a:rPr/>
               <a:t>Machine learning uses a CPU ONNX V3 model discovered from the bundled models directory.</a:t>
             </a:r>
           </a:p>
@@ -5479,13 +5362,9 @@
               <a:spcAft>
                 <a:spcPts val="400"/>
               </a:spcAft>
-              <a:defRPr sz="1600">
-                <a:solidFill>
-                  <a:srgbClr val="222222"/>
-                </a:solidFill>
-              </a:defRPr>
             </a:pPr>
             <a:r>
+              <a:rPr/>
               <a:t>Model contract verified from checkpoint and ONNX metadata: 16 kHz, 512 FFT / 256 hop, 257 frequency bins, normalized magnitude input, normalized enhanced magnitude output.</a:t>
             </a:r>
           </a:p>
@@ -5494,13 +5373,9 @@
               <a:spcAft>
                 <a:spcPts val="400"/>
               </a:spcAft>
-              <a:defRPr sz="1600">
-                <a:solidFill>
-                  <a:srgbClr val="222222"/>
-                </a:solidFill>
-              </a:defRPr>
             </a:pPr>
             <a:r>
+              <a:rPr/>
               <a:t>Preprocessing: resample to 16 kHz, STFT, magnitude extraction, normalization; postprocessing: inference, inverse scaling, phase reuse, inverse STFT, output length restoration, clipping protection.</a:t>
             </a:r>
           </a:p>
@@ -5509,13 +5384,9 @@
               <a:spcAft>
                 <a:spcPts val="400"/>
               </a:spcAft>
-              <a:defRPr sz="1600">
-                <a:solidFill>
-                  <a:srgbClr val="222222"/>
-                </a:solidFill>
-              </a:defRPr>
             </a:pPr>
             <a:r>
+              <a:rPr/>
               <a:t>Hybrid mode performs ML enhancement first and then applies DSP enhancement to the ML result (verified in workflow.py).</a:t>
             </a:r>
           </a:p>
@@ -5524,13 +5395,9 @@
               <a:spcAft>
                 <a:spcPts val="400"/>
               </a:spcAft>
-              <a:defRPr sz="1600">
-                <a:solidFill>
-                  <a:srgbClr val="222222"/>
-                </a:solidFill>
-              </a:defRPr>
             </a:pPr>
             <a:r>
+              <a:rPr/>
               <a:t>All reported SNR gains come from synthetic clean-speech plus noise tests; subjective quality and clean-speech reference measurements remain necessary for stronger claims.</a:t>
             </a:r>
           </a:p>
@@ -5578,7 +5445,7 @@
 </file>
 
 <file path=ppt/slides/slide7.xml><?xml version="1.0" encoding="utf-8"?>
-<p:sld xmlns:a="http://schemas.openxmlformats.org/drawingml/2006/main" xmlns:p="http://schemas.openxmlformats.org/presentationml/2006/main" xmlns:r="http://schemas.openxmlformats.org/officeDocument/2006/relationships">
+<p:sld xmlns:a="http://schemas.openxmlformats.org/drawingml/2006/main" xmlns:r="http://schemas.openxmlformats.org/officeDocument/2006/relationships" xmlns:p="http://schemas.openxmlformats.org/presentationml/2006/main">
   <p:cSld>
     <p:spTree>
       <p:nvGrpSpPr>
@@ -5586,7 +5453,14 @@
         <p:cNvGrpSpPr/>
         <p:nvPr/>
       </p:nvGrpSpPr>
-      <p:grpSpPr/>
+      <p:grpSpPr>
+        <a:xfrm>
+          <a:off x="0" y="0"/>
+          <a:ext cx="0" cy="0"/>
+          <a:chOff x="0" y="0"/>
+          <a:chExt cx="0" cy="0"/>
+        </a:xfrm>
+      </p:grpSpPr>
       <p:sp>
         <p:nvSpPr>
           <p:cNvPr id="2" name="TextBox 1"/>
@@ -5646,13 +5520,9 @@
               <a:spcAft>
                 <a:spcPts val="400"/>
               </a:spcAft>
-              <a:defRPr sz="1600">
-                <a:solidFill>
-                  <a:srgbClr val="222222"/>
-                </a:solidFill>
-              </a:defRPr>
             </a:pPr>
             <a:r>
+              <a:rPr/>
               <a:t>The GUI has device selection, method selection, noise-reduction and voice-preservation controls, level meters, start/stop controls, recording/analysis, plots, and status text.</a:t>
             </a:r>
           </a:p>
@@ -5661,13 +5531,9 @@
               <a:spcAft>
                 <a:spcPts val="400"/>
               </a:spcAft>
-              <a:defRPr sz="1600">
-                <a:solidFill>
-                  <a:srgbClr val="222222"/>
-                </a:solidFill>
-              </a:defRPr>
             </a:pPr>
             <a:r>
+              <a:rPr/>
               <a:t>Live route: physical microphone -&gt; one capture stream -&gt; enhancement worker -&gt; one virtual audio destination.</a:t>
             </a:r>
           </a:p>
@@ -5676,13 +5542,9 @@
               <a:spcAft>
                 <a:spcPts val="400"/>
               </a:spcAft>
-              <a:defRPr sz="1600">
-                <a:solidFill>
-                  <a:srgbClr val="222222"/>
-                </a:solidFill>
-              </a:defRPr>
             </a:pPr>
             <a:r>
+              <a:rPr/>
               <a:t>Optional monitoring route: enhanced output -&gt; headphones or speakers only when enabled. This is disabled by default to reduce acoustic feedback.</a:t>
             </a:r>
           </a:p>
@@ -5691,13 +5553,9 @@
               <a:spcAft>
                 <a:spcPts val="400"/>
               </a:spcAft>
-              <a:defRPr sz="1600">
-                <a:solidFill>
-                  <a:srgbClr val="222222"/>
-                </a:solidFill>
-              </a:defRPr>
             </a:pPr>
             <a:r>
+              <a:rPr/>
               <a:t>Virtual playback/render endpoint and the corresponding virtual recording/capture endpoint are not the same device; both are shown with actual device names.</a:t>
             </a:r>
           </a:p>
@@ -5706,13 +5564,9 @@
               <a:spcAft>
                 <a:spcPts val="400"/>
               </a:spcAft>
-              <a:defRPr sz="1600">
-                <a:solidFill>
-                  <a:srgbClr val="222222"/>
-                </a:solidFill>
-              </a:defRPr>
             </a:pPr>
             <a:r>
+              <a:rPr/>
               <a:t>Diagnostics include selected/actual device identifiers, sample rate, channels, peak, RMS, latency, queue depth, underflows, overflows, model status, and errors.</a:t>
             </a:r>
           </a:p>
@@ -5744,13 +5598,9 @@
               <a:spcAft>
                 <a:spcPts val="400"/>
               </a:spcAft>
-              <a:defRPr sz="1400">
-                <a:solidFill>
-                  <a:srgbClr val="222222"/>
-                </a:solidFill>
-              </a:defRPr>
             </a:pPr>
             <a:r>
+              <a:rPr/>
               <a:t>Meeting-app integration concept: enhanced speech -&gt; virtual render endpoint -&gt; virtual capture endpoint -&gt; Google Meet/Teams/Zoom microphone selection.</a:t>
             </a:r>
           </a:p>
@@ -5759,13 +5609,9 @@
               <a:spcAft>
                 <a:spcPts val="400"/>
               </a:spcAft>
-              <a:defRPr sz="1400">
-                <a:solidFill>
-                  <a:srgbClr val="222222"/>
-                </a:solidFill>
-              </a:defRPr>
             </a:pPr>
             <a:r>
+              <a:rPr/>
               <a:t>Not physically verified in this workspace.</a:t>
             </a:r>
           </a:p>
@@ -5813,7 +5659,7 @@
 </file>
 
 <file path=ppt/slides/slide8.xml><?xml version="1.0" encoding="utf-8"?>
-<p:sld xmlns:a="http://schemas.openxmlformats.org/drawingml/2006/main" xmlns:p="http://schemas.openxmlformats.org/presentationml/2006/main" xmlns:r="http://schemas.openxmlformats.org/officeDocument/2006/relationships">
+<p:sld xmlns:a="http://schemas.openxmlformats.org/drawingml/2006/main" xmlns:r="http://schemas.openxmlformats.org/officeDocument/2006/relationships" xmlns:p="http://schemas.openxmlformats.org/presentationml/2006/main">
   <p:cSld>
     <p:spTree>
       <p:nvGrpSpPr>
@@ -5821,7 +5667,14 @@
         <p:cNvGrpSpPr/>
         <p:nvPr/>
       </p:nvGrpSpPr>
-      <p:grpSpPr/>
+      <p:grpSpPr>
+        <a:xfrm>
+          <a:off x="0" y="0"/>
+          <a:ext cx="0" cy="0"/>
+          <a:chOff x="0" y="0"/>
+          <a:chExt cx="0" cy="0"/>
+        </a:xfrm>
+      </p:grpSpPr>
       <p:sp>
         <p:nvSpPr>
           <p:cNvPr id="2" name="TextBox 1"/>
@@ -5881,13 +5734,9 @@
               <a:spcAft>
                 <a:spcPts val="400"/>
               </a:spcAft>
-              <a:defRPr sz="1600">
-                <a:solidFill>
-                  <a:srgbClr val="222222"/>
-                </a:solidFill>
-              </a:defRPr>
             </a:pPr>
             <a:r>
+              <a:rPr/>
               <a:t>Evaluation script uses 3.0 seconds of synthetic speech at 16 kHz.</a:t>
             </a:r>
           </a:p>
@@ -5896,13 +5745,9 @@
               <a:spcAft>
                 <a:spcPts val="400"/>
               </a:spcAft>
-              <a:defRPr sz="1600">
-                <a:solidFill>
-                  <a:srgbClr val="222222"/>
-                </a:solidFill>
-              </a:defRPr>
             </a:pPr>
             <a:r>
+              <a:rPr/>
               <a:t>Noise cases: white (10 dB target SNR), babble (8 dB), changing (12 dB).</a:t>
             </a:r>
           </a:p>
@@ -5911,13 +5756,9 @@
               <a:spcAft>
                 <a:spcPts val="400"/>
               </a:spcAft>
-              <a:defRPr sz="1600">
-                <a:solidFill>
-                  <a:srgbClr val="222222"/>
-                </a:solidFill>
-              </a:defRPr>
             </a:pPr>
             <a:r>
+              <a:rPr/>
               <a:t>Each configured mode receives the same noisy input for a controlled comparison.</a:t>
             </a:r>
           </a:p>
@@ -5926,13 +5767,9 @@
               <a:spcAft>
                 <a:spcPts val="400"/>
               </a:spcAft>
-              <a:defRPr sz="1600">
-                <a:solidFill>
-                  <a:srgbClr val="222222"/>
-                </a:solidFill>
-              </a:defRPr>
             </a:pPr>
             <a:r>
+              <a:rPr/>
               <a:t>Offline metrics: RMS, peak amplitude, SNR, SNR improvement, processing time, and real-time factor.</a:t>
             </a:r>
           </a:p>
@@ -5941,13 +5778,9 @@
               <a:spcAft>
                 <a:spcPts val="400"/>
               </a:spcAft>
-              <a:defRPr sz="1600">
-                <a:solidFill>
-                  <a:srgbClr val="222222"/>
-                </a:solidFill>
-              </a:defRPr>
             </a:pPr>
             <a:r>
+              <a:rPr/>
               <a:t>Automated tests: 17 passed in the current workspace.</a:t>
             </a:r>
           </a:p>
@@ -5956,13 +5789,9 @@
               <a:spcAft>
                 <a:spcPts val="400"/>
               </a:spcAft>
-              <a:defRPr sz="1600">
-                <a:solidFill>
-                  <a:srgbClr val="222222"/>
-                </a:solidFill>
-              </a:defRPr>
             </a:pPr>
             <a:r>
+              <a:rPr/>
               <a:t>Missing/unverified support: clean live-speech reference, physical microphone tests, subjective listening tests, and meeting-application tests.</a:t>
             </a:r>
           </a:p>
@@ -6010,7 +5839,7 @@
 </file>
 
 <file path=ppt/slides/slide9.xml><?xml version="1.0" encoding="utf-8"?>
-<p:sld xmlns:a="http://schemas.openxmlformats.org/drawingml/2006/main" xmlns:p="http://schemas.openxmlformats.org/presentationml/2006/main" xmlns:r="http://schemas.openxmlformats.org/officeDocument/2006/relationships">
+<p:sld xmlns:a="http://schemas.openxmlformats.org/drawingml/2006/main" xmlns:r="http://schemas.openxmlformats.org/officeDocument/2006/relationships" xmlns:p="http://schemas.openxmlformats.org/presentationml/2006/main">
   <p:cSld>
     <p:spTree>
       <p:nvGrpSpPr>
@@ -6018,7 +5847,14 @@
         <p:cNvGrpSpPr/>
         <p:nvPr/>
       </p:nvGrpSpPr>
-      <p:grpSpPr/>
+      <p:grpSpPr>
+        <a:xfrm>
+          <a:off x="0" y="0"/>
+          <a:ext cx="0" cy="0"/>
+          <a:chOff x="0" y="0"/>
+          <a:chExt cx="0" cy="0"/>
+        </a:xfrm>
+      </p:grpSpPr>
       <p:sp>
         <p:nvSpPr>
           <p:cNvPr id="2" name="TextBox 1"/>
@@ -6061,7 +5897,7 @@
           <p:nvPr/>
         </p:nvGraphicFramePr>
         <p:xfrm>
-          <a:off x="822960" y="1645920"/>
+          <a:off x="685800" y="838200"/>
           <a:ext cx="10332720" cy="1554480"/>
         </p:xfrm>
         <a:graphic>
@@ -6434,8 +6270,8 @@
         </p:nvSpPr>
         <p:spPr>
           <a:xfrm>
-            <a:off x="731520" y="3383280"/>
-            <a:ext cx="10698480" cy="4663440"/>
+            <a:off x="594146" y="2514600"/>
+            <a:ext cx="10835854" cy="1107440"/>
           </a:xfrm>
           <a:prstGeom prst="rect">
             <a:avLst/>
@@ -6452,13 +6288,9 @@
               <a:spcAft>
                 <a:spcPts val="400"/>
               </a:spcAft>
-              <a:defRPr sz="1400">
-                <a:solidFill>
-                  <a:srgbClr val="222222"/>
-                </a:solidFill>
-              </a:defRPr>
             </a:pPr>
             <a:r>
+              <a:rPr/>
               <a:t>DSP RTF in the synthetic evaluation: 0.0109. ML average processing time: 0.0740 s per 3.0 s block.</a:t>
             </a:r>
           </a:p>
@@ -6467,13 +6299,9 @@
               <a:spcAft>
                 <a:spcPts val="400"/>
               </a:spcAft>
-              <a:defRPr sz="1400">
-                <a:solidFill>
-                  <a:srgbClr val="222222"/>
-                </a:solidFill>
-              </a:defRPr>
             </a:pPr>
             <a:r>
+              <a:rPr/>
               <a:t>Lower RMS or lower SNR does not automatically prove better intelligibility; speech preservation requires listening tests.</a:t>
             </a:r>
           </a:p>
@@ -6482,13 +6310,9 @@
               <a:spcAft>
                 <a:spcPts val="400"/>
               </a:spcAft>
-              <a:defRPr sz="1400">
-                <a:solidFill>
-                  <a:srgbClr val="222222"/>
-                </a:solidFill>
-              </a:defRPr>
             </a:pPr>
             <a:r>
+              <a:rPr/>
               <a:t>SNR values use the synthetic clean reference generated by the evaluation script, not a live microphone recording.</a:t>
             </a:r>
           </a:p>
@@ -6502,7 +6326,7 @@
           </p:cNvPicPr>
           <p:nvPr/>
         </p:nvPicPr>
-        <p:blipFill>
+        <p:blipFill rotWithShape="1">
           <a:blip r:embed="rId2"/>
           <a:stretch>
             <a:fillRect/>
@@ -6526,7 +6350,7 @@
           </p:cNvPicPr>
           <p:nvPr/>
         </p:nvPicPr>
-        <p:blipFill>
+        <p:blipFill rotWithShape="1">
           <a:blip r:embed="rId3"/>
           <a:stretch>
             <a:fillRect/>
@@ -6584,14 +6408,14 @@
 </file>
 
 <file path=ppt/theme/theme1.xml><?xml version="1.0" encoding="utf-8"?>
-<a:theme xmlns:a="http://schemas.openxmlformats.org/drawingml/2006/main" name="Office Theme">
+<a:theme xmlns:a="http://schemas.openxmlformats.org/drawingml/2006/main" xmlns:r="http://schemas.openxmlformats.org/officeDocument/2006/relationships" name="Office Theme">
   <a:themeElements>
     <a:clrScheme name="Office">
       <a:dk1>
-        <a:sysClr val="windowText" lastClr="000000"/>
+        <a:srgbClr val="000000"/>
       </a:dk1>
       <a:lt1>
-        <a:sysClr val="window" lastClr="FFFFFF"/>
+        <a:srgbClr val="FFFFFF"/>
       </a:lt1>
       <a:dk2>
         <a:srgbClr val="1F497D"/>
@@ -6745,7 +6569,7 @@
         </a:gradFill>
       </a:fillStyleLst>
       <a:lnStyleLst>
-        <a:ln w="9525" cap="flat" cmpd="sng" algn="ctr">
+        <a:ln w="9525" cap="flat" cmpd="sng">
           <a:solidFill>
             <a:schemeClr val="phClr">
               <a:shade val="95000"/>
@@ -6754,13 +6578,13 @@
           </a:solidFill>
           <a:prstDash val="solid"/>
         </a:ln>
-        <a:ln w="25400" cap="flat" cmpd="sng" algn="ctr">
+        <a:ln w="25400" cap="flat" cmpd="sng">
           <a:solidFill>
             <a:schemeClr val="phClr"/>
           </a:solidFill>
           <a:prstDash val="solid"/>
         </a:ln>
-        <a:ln w="38100" cap="flat" cmpd="sng" algn="ctr">
+        <a:ln w="38100" cap="flat" cmpd="sng">
           <a:solidFill>
             <a:schemeClr val="phClr"/>
           </a:solidFill>
@@ -6770,7 +6594,7 @@
       <a:effectStyleLst>
         <a:effectStyle>
           <a:effectLst>
-            <a:outerShdw blurRad="40000" dist="20000" dir="5400000" rotWithShape="0">
+            <a:outerShdw blurRad="40000" dist="20000" dir="5400000" algn="b" rotWithShape="0">
               <a:srgbClr val="000000">
                 <a:alpha val="38000"/>
               </a:srgbClr>
@@ -6779,7 +6603,7 @@
         </a:effectStyle>
         <a:effectStyle>
           <a:effectLst>
-            <a:outerShdw blurRad="40000" dist="23000" dir="5400000" rotWithShape="0">
+            <a:outerShdw blurRad="40000" dist="23000" dir="5400000" algn="b" rotWithShape="0">
               <a:srgbClr val="000000">
                 <a:alpha val="35000"/>
               </a:srgbClr>
@@ -6788,13 +6612,13 @@
         </a:effectStyle>
         <a:effectStyle>
           <a:effectLst>
-            <a:outerShdw blurRad="40000" dist="23000" dir="5400000" rotWithShape="0">
+            <a:outerShdw blurRad="40000" dist="23000" dir="5400000" algn="b" rotWithShape="0">
               <a:srgbClr val="000000">
                 <a:alpha val="35000"/>
               </a:srgbClr>
             </a:outerShdw>
           </a:effectLst>
-          <a:scene3d>
+          <a:scene3d xmlns:a="http://schemas.openxmlformats.org/drawingml/2006/main">
             <a:camera prst="orthographicFront">
               <a:rot lat="0" lon="0" rev="0"/>
             </a:camera>
@@ -6802,7 +6626,7 @@
               <a:rot lat="0" lon="0" rev="1200000"/>
             </a:lightRig>
           </a:scene3d>
-          <a:sp3d>
+          <a:sp3d xmlns:a="http://schemas.openxmlformats.org/drawingml/2006/main">
             <a:bevelT w="63500" h="25400"/>
           </a:sp3d>
         </a:effectStyle>
@@ -6859,7 +6683,7 @@
       </a:bgFillStyleLst>
     </a:fmtScheme>
   </a:themeElements>
-  <a:objectDefaults>
+  <a:objectDefaults xmlns:a="http://schemas.openxmlformats.org/drawingml/2006/main">
     <a:spDef>
       <a:spPr/>
       <a:bodyPr/>
@@ -6899,6 +6723,6 @@
       </a:style>
     </a:lnDef>
   </a:objectDefaults>
-  <a:extraClrSchemeLst/>
+  <a:extraClrSchemeLst xmlns:a="http://schemas.openxmlformats.org/drawingml/2006/main"/>
 </a:theme>
 </file>
</xml_diff>